<commit_message>
Lead the deck with the completed August run
The roster shows August already sent: all 15 eligible recipients, zero
missed, with the one person on leave auto-excluded. That turns the deck
from a proposal into a proven deployment, so add a results slide with
those figures and the three things the run verified, badge the title
slide, and qualify the impact slide's estimate against the measured
accuracy.

Co-Authored-By: Claude Opus 4.8 <noreply@anthropic.com>
Claude-Session: https://claude.ai/code/session_01XuLv3pYJEiSSQ56Q9hqZcY
</commit_message>
<xml_diff>
--- a/bureung-automation/생일휴가_자동화_PT.pptx
+++ b/bureung-automation/생일휴가_자동화_PT.pptx
@@ -14,9 +14,10 @@
     <p:sldId id="262" r:id="rId8"/>
     <p:sldId id="263" r:id="rId9"/>
     <p:sldId id="264" r:id="rId10"/>
+    <p:sldId id="265" r:id="rId11"/>
   </p:sldIdLst>
   <p:notesMasterIdLst>
-    <p:notesMasterId r:id="rId11"/>
+    <p:notesMasterId r:id="rId12"/>
   </p:notesMasterIdLst>
   <p:sldSz cx="12192000" cy="6858000"/>
   <p:notesSz cx="6858000" cy="12192000"/>
@@ -847,6 +848,94 @@
 </p:notes>
 </file>
 
+<file path=ppt/notesSlides/notesSlide10.xml><?xml version="1.0" encoding="utf-8"?>
+<p:notes xmlns:a="http://schemas.openxmlformats.org/drawingml/2006/main" xmlns:r="http://schemas.openxmlformats.org/officeDocument/2006/relationships" xmlns:p="http://schemas.openxmlformats.org/presentationml/2006/main">
+  <p:cSld>
+    <p:spTree>
+      <p:nvGrpSpPr>
+        <p:cNvPr id="1" name=""/>
+        <p:cNvGrpSpPr/>
+        <p:nvPr/>
+      </p:nvGrpSpPr>
+      <p:grpSpPr>
+        <a:xfrm>
+          <a:off x="0" y="0"/>
+          <a:ext cx="0" cy="0"/>
+          <a:chOff x="0" y="0"/>
+          <a:chExt cx="0" cy="0"/>
+        </a:xfrm>
+      </p:grpSpPr>
+      <p:sp>
+        <p:nvSpPr>
+          <p:cNvPr id="2" name="Slide Image Placeholder 1"/>
+          <p:cNvSpPr>
+            <a:spLocks noGrp="1" noRot="1" noChangeAspect="1"/>
+          </p:cNvSpPr>
+          <p:nvPr>
+            <p:ph type="sldImg"/>
+          </p:nvPr>
+        </p:nvSpPr>
+        <p:spPr/>
+      </p:sp>
+      <p:sp>
+        <p:nvSpPr>
+          <p:cNvPr id="3" name="Notes Placeholder 2"/>
+          <p:cNvSpPr>
+            <a:spLocks noGrp="1"/>
+          </p:cNvSpPr>
+          <p:nvPr>
+            <p:ph type="body" idx="1"/>
+          </p:nvPr>
+        </p:nvSpPr>
+        <p:spPr/>
+        <p:txBody>
+          <a:bodyPr/>
+          <a:lstStyle/>
+          <a:p>
+            <a:r>
+              <a:rPr lang="en-US" dirty="0"/>
+              <a:t>질문 받겠습니다.</a:t>
+            </a:r>
+            <a:endParaRPr lang="en-US" dirty="0"/>
+          </a:p>
+        </p:txBody>
+      </p:sp>
+      <p:sp>
+        <p:nvSpPr>
+          <p:cNvPr id="4" name="Slide Number Placeholder 3"/>
+          <p:cNvSpPr>
+            <a:spLocks noGrp="1"/>
+          </p:cNvSpPr>
+          <p:nvPr>
+            <p:ph type="sldNum" sz="quarter" idx="10"/>
+          </p:nvPr>
+        </p:nvSpPr>
+        <p:spPr/>
+        <p:txBody>
+          <a:bodyPr/>
+          <a:lstStyle/>
+          <a:p>
+            <a:fld id="{F7021451-1387-4CA6-816F-3879F97B5CBC}" type="slidenum">
+              <a:rPr lang="en-US"/>
+              <a:t>10</a:t>
+            </a:fld>
+            <a:endParaRPr lang="en-US"/>
+          </a:p>
+        </p:txBody>
+      </p:sp>
+    </p:spTree>
+    <p:extLst>
+      <p:ext uri="{BB962C8B-B14F-4D97-AF65-F5344CB8AC3E}">
+        <p14:creationId xmlns:p14="http://schemas.microsoft.com/office/powerpoint/2010/main" val="1024086991"/>
+      </p:ext>
+    </p:extLst>
+  </p:cSld>
+  <p:clrMapOvr>
+    <a:masterClrMapping/>
+  </p:clrMapOvr>
+</p:notes>
+</file>
+
 <file path=ppt/notesSlides/notesSlide2.xml><?xml version="1.0" encoding="utf-8"?>
 <p:notes xmlns:a="http://schemas.openxmlformats.org/drawingml/2006/main" xmlns:r="http://schemas.openxmlformats.org/officeDocument/2006/relationships" xmlns:p="http://schemas.openxmlformats.org/presentationml/2006/main">
   <p:cSld>
@@ -1333,7 +1422,7 @@
           <a:p>
             <a:r>
               <a:rPr lang="en-US" dirty="0"/>
-              <a:t>이 부분이 이번 작업에서 가장 신경 쓴 지점입니다. 인턴이 만든 도구는 인턴이 떠나면 멈추기 쉬운데, 그렇게 되지 않도록 설정과 문서를 도구 안에 넣었습니다.</a:t>
+              <a:t>가장 중요한 슬라이드입니다. 아이디어 단계가 아니라 8월 안내를 실제로 이 도구로 발송했고, 대상자 15명 전원에게 누락 없이 나갔습니다. 휴직자 한 분은 규칙에 따라 자동으로 제외됐습니다.</a:t>
             </a:r>
             <a:endParaRPr lang="en-US" dirty="0"/>
           </a:p>
@@ -1421,7 +1510,7 @@
           <a:p>
             <a:r>
               <a:rPr lang="en-US" dirty="0"/>
-              <a:t>시간 절감도 크지만, 더 중요한 것은 담당자가 바뀌어도 같은 품질이 유지된다는 점입니다.</a:t>
+              <a:t>이 부분이 이번 작업에서 가장 신경 쓴 지점입니다. 인턴이 만든 도구는 인턴이 떠나면 멈추기 쉬운데, 그렇게 되지 않도록 설정과 문서를 도구 안에 넣었습니다.</a:t>
             </a:r>
             <a:endParaRPr lang="en-US" dirty="0"/>
           </a:p>
@@ -1509,7 +1598,7 @@
           <a:p>
             <a:r>
               <a:rPr lang="en-US" dirty="0"/>
-              <a:t>질문 받겠습니다.</a:t>
+              <a:t>시간 절감도 크지만, 더 중요한 것은 담당자가 바뀌어도 같은 품질이 유지된다는 점입니다. 정확도는 8월 운영에서 이미 확인했습니다.</a:t>
             </a:r>
             <a:endParaRPr lang="en-US" dirty="0"/>
           </a:p>
@@ -2047,11 +2136,13 @@
         </p:nvSpPr>
         <p:spPr>
           <a:xfrm>
-            <a:off x="685800" y="3977640"/>
-            <a:ext cx="1005840" cy="41148"/>
-          </a:xfrm>
-          <a:prstGeom prst="rect">
-            <a:avLst/>
+            <a:off x="685800" y="3886200"/>
+            <a:ext cx="2880360" cy="457200"/>
+          </a:xfrm>
+          <a:prstGeom prst="roundRect">
+            <a:avLst>
+              <a:gd name="adj" fmla="val 20000"/>
+            </a:avLst>
           </a:prstGeom>
           <a:solidFill>
             <a:srgbClr val="00C878"/>
@@ -2067,7 +2158,46 @@
         </p:nvSpPr>
         <p:spPr>
           <a:xfrm>
-            <a:off x="685800" y="4251960"/>
+            <a:off x="685800" y="3886200"/>
+            <a:ext cx="2880360" cy="457200"/>
+          </a:xfrm>
+          <a:prstGeom prst="rect">
+            <a:avLst/>
+          </a:prstGeom>
+          <a:noFill/>
+          <a:ln/>
+        </p:spPr>
+        <p:txBody>
+          <a:bodyPr wrap="square" lIns="0" tIns="0" rIns="0" bIns="0" rtlCol="0" anchor="ctr"/>
+          <a:lstStyle/>
+          <a:p>
+            <a:pPr algn="ctr" indent="0" marL="0">
+              <a:buNone/>
+            </a:pPr>
+            <a:r>
+              <a:rPr lang="en-US" sz="1400" b="1" dirty="0">
+                <a:solidFill>
+                  <a:srgbClr val="06301F"/>
+                </a:solidFill>
+                <a:latin typeface="Calibri" pitchFamily="34" charset="0"/>
+                <a:ea typeface="Calibri" pitchFamily="34" charset="-122"/>
+                <a:cs typeface="Calibri" pitchFamily="34" charset="-120"/>
+              </a:rPr>
+              <a:t>2026년 8월 운영 완료</a:t>
+            </a:r>
+            <a:endParaRPr lang="en-US" sz="1400" dirty="0"/>
+          </a:p>
+        </p:txBody>
+      </p:sp>
+      <p:sp>
+        <p:nvSpPr>
+          <p:cNvPr id="9" name="Text 7"/>
+          <p:cNvSpPr/>
+          <p:nvPr/>
+        </p:nvSpPr>
+        <p:spPr>
+          <a:xfrm>
+            <a:off x="685800" y="4617720"/>
             <a:ext cx="5486400" cy="320040"/>
           </a:xfrm>
           <a:prstGeom prst="rect">
@@ -2095,6 +2225,628 @@
               <a:t>피플실  |  2026. 08</a:t>
             </a:r>
             <a:endParaRPr lang="en-US" sz="1400" dirty="0"/>
+          </a:p>
+        </p:txBody>
+      </p:sp>
+    </p:spTree>
+  </p:cSld>
+  <p:clrMapOvr>
+    <a:masterClrMapping/>
+  </p:clrMapOvr>
+</p:sld>
+</file>
+
+<file path=ppt/slides/slide10.xml><?xml version="1.0" encoding="utf-8"?>
+<p:sld xmlns:a="http://schemas.openxmlformats.org/drawingml/2006/main" xmlns:r="http://schemas.openxmlformats.org/officeDocument/2006/relationships" xmlns:p="http://schemas.openxmlformats.org/presentationml/2006/main">
+  <p:cSld name="Slide 10">
+    <p:bg>
+      <p:bgPr>
+        <a:solidFill>
+          <a:srgbClr val="0E2A22"/>
+        </a:solidFill>
+      </p:bgPr>
+    </p:bg>
+    <p:spTree>
+      <p:nvGrpSpPr>
+        <p:cNvPr id="1" name=""/>
+        <p:cNvGrpSpPr/>
+        <p:nvPr/>
+      </p:nvGrpSpPr>
+      <p:grpSpPr>
+        <a:xfrm>
+          <a:off x="0" y="0"/>
+          <a:ext cx="0" cy="0"/>
+          <a:chOff x="0" y="0"/>
+          <a:chExt cx="0" cy="0"/>
+        </a:xfrm>
+      </p:grpSpPr>
+      <p:sp>
+        <p:nvSpPr>
+          <p:cNvPr id="2" name="Shape 0"/>
+          <p:cNvSpPr/>
+          <p:nvPr/>
+        </p:nvSpPr>
+        <p:spPr>
+          <a:xfrm>
+            <a:off x="10241280" y="-1097280"/>
+            <a:ext cx="3474720" cy="3474720"/>
+          </a:xfrm>
+          <a:prstGeom prst="ellipse">
+            <a:avLst/>
+          </a:prstGeom>
+          <a:solidFill>
+            <a:srgbClr val="173A2E"/>
+          </a:solidFill>
+          <a:ln/>
+        </p:spPr>
+      </p:sp>
+      <p:sp>
+        <p:nvSpPr>
+          <p:cNvPr id="3" name="Text 1"/>
+          <p:cNvSpPr/>
+          <p:nvPr/>
+        </p:nvSpPr>
+        <p:spPr>
+          <a:xfrm>
+            <a:off x="685800" y="685800"/>
+            <a:ext cx="10817352" cy="731520"/>
+          </a:xfrm>
+          <a:prstGeom prst="rect">
+            <a:avLst/>
+          </a:prstGeom>
+          <a:noFill/>
+          <a:ln/>
+        </p:spPr>
+        <p:txBody>
+          <a:bodyPr wrap="square" lIns="0" tIns="0" rIns="0" bIns="0" rtlCol="0" anchor="ctr"/>
+          <a:lstStyle/>
+          <a:p>
+            <a:pPr indent="0" marL="0">
+              <a:buNone/>
+            </a:pPr>
+            <a:r>
+              <a:rPr lang="en-US" sz="3800" b="1" dirty="0">
+                <a:solidFill>
+                  <a:srgbClr val="FFFFFF"/>
+                </a:solidFill>
+                <a:latin typeface="Calibri" pitchFamily="34" charset="0"/>
+                <a:ea typeface="Calibri" pitchFamily="34" charset="-122"/>
+                <a:cs typeface="Calibri" pitchFamily="34" charset="-120"/>
+              </a:rPr>
+              <a:t>향후 계획</a:t>
+            </a:r>
+            <a:endParaRPr lang="en-US" sz="3800" dirty="0"/>
+          </a:p>
+        </p:txBody>
+      </p:sp>
+      <p:sp>
+        <p:nvSpPr>
+          <p:cNvPr id="4" name="Shape 2"/>
+          <p:cNvSpPr/>
+          <p:nvPr/>
+        </p:nvSpPr>
+        <p:spPr>
+          <a:xfrm>
+            <a:off x="685800" y="1828800"/>
+            <a:ext cx="10817352" cy="960120"/>
+          </a:xfrm>
+          <a:prstGeom prst="roundRect">
+            <a:avLst>
+              <a:gd name="adj" fmla="val 7619"/>
+            </a:avLst>
+          </a:prstGeom>
+          <a:solidFill>
+            <a:srgbClr val="15352A"/>
+          </a:solidFill>
+          <a:ln w="12700">
+            <a:solidFill>
+              <a:srgbClr val="15352A"/>
+            </a:solidFill>
+            <a:prstDash val="solid"/>
+          </a:ln>
+        </p:spPr>
+      </p:sp>
+      <p:sp>
+        <p:nvSpPr>
+          <p:cNvPr id="5" name="Shape 3"/>
+          <p:cNvSpPr/>
+          <p:nvPr/>
+        </p:nvSpPr>
+        <p:spPr>
+          <a:xfrm>
+            <a:off x="1005840" y="2084832"/>
+            <a:ext cx="438912" cy="438912"/>
+          </a:xfrm>
+          <a:prstGeom prst="ellipse">
+            <a:avLst/>
+          </a:prstGeom>
+          <a:solidFill>
+            <a:srgbClr val="00C878"/>
+          </a:solidFill>
+          <a:ln/>
+        </p:spPr>
+      </p:sp>
+      <p:sp>
+        <p:nvSpPr>
+          <p:cNvPr id="6" name="Text 4"/>
+          <p:cNvSpPr/>
+          <p:nvPr/>
+        </p:nvSpPr>
+        <p:spPr>
+          <a:xfrm>
+            <a:off x="1005840" y="2084832"/>
+            <a:ext cx="438912" cy="438912"/>
+          </a:xfrm>
+          <a:prstGeom prst="rect">
+            <a:avLst/>
+          </a:prstGeom>
+          <a:noFill/>
+          <a:ln/>
+        </p:spPr>
+        <p:txBody>
+          <a:bodyPr wrap="square" lIns="0" tIns="0" rIns="0" bIns="0" rtlCol="0" anchor="ctr"/>
+          <a:lstStyle/>
+          <a:p>
+            <a:pPr algn="ctr" indent="0" marL="0">
+              <a:buNone/>
+            </a:pPr>
+            <a:r>
+              <a:rPr lang="en-US" sz="1400" b="1" dirty="0">
+                <a:solidFill>
+                  <a:srgbClr val="FFFFFF"/>
+                </a:solidFill>
+                <a:latin typeface="Calibri" pitchFamily="34" charset="0"/>
+                <a:ea typeface="Calibri" pitchFamily="34" charset="-122"/>
+                <a:cs typeface="Calibri" pitchFamily="34" charset="-120"/>
+              </a:rPr>
+              <a:t>1</a:t>
+            </a:r>
+            <a:endParaRPr lang="en-US" sz="1400" dirty="0"/>
+          </a:p>
+        </p:txBody>
+      </p:sp>
+      <p:sp>
+        <p:nvSpPr>
+          <p:cNvPr id="7" name="Text 5"/>
+          <p:cNvSpPr/>
+          <p:nvPr/>
+        </p:nvSpPr>
+        <p:spPr>
+          <a:xfrm>
+            <a:off x="1645920" y="1956816"/>
+            <a:ext cx="3291840" cy="365760"/>
+          </a:xfrm>
+          <a:prstGeom prst="rect">
+            <a:avLst/>
+          </a:prstGeom>
+          <a:noFill/>
+          <a:ln/>
+        </p:spPr>
+        <p:txBody>
+          <a:bodyPr wrap="square" lIns="0" tIns="0" rIns="0" bIns="0" rtlCol="0" anchor="ctr"/>
+          <a:lstStyle/>
+          <a:p>
+            <a:pPr indent="0" marL="0">
+              <a:buNone/>
+            </a:pPr>
+            <a:r>
+              <a:rPr lang="en-US" sz="1700" b="1" dirty="0">
+                <a:solidFill>
+                  <a:srgbClr val="FFFFFF"/>
+                </a:solidFill>
+                <a:latin typeface="Calibri" pitchFamily="34" charset="0"/>
+                <a:ea typeface="Calibri" pitchFamily="34" charset="-122"/>
+                <a:cs typeface="Calibri" pitchFamily="34" charset="-120"/>
+              </a:rPr>
+              <a:t>회사 로고 서명 적용</a:t>
+            </a:r>
+            <a:endParaRPr lang="en-US" sz="1700" dirty="0"/>
+          </a:p>
+        </p:txBody>
+      </p:sp>
+      <p:sp>
+        <p:nvSpPr>
+          <p:cNvPr id="8" name="Text 6"/>
+          <p:cNvSpPr/>
+          <p:nvPr/>
+        </p:nvSpPr>
+        <p:spPr>
+          <a:xfrm>
+            <a:off x="5120640" y="1956816"/>
+            <a:ext cx="6062472" cy="704088"/>
+          </a:xfrm>
+          <a:prstGeom prst="rect">
+            <a:avLst/>
+          </a:prstGeom>
+          <a:noFill/>
+          <a:ln/>
+        </p:spPr>
+        <p:txBody>
+          <a:bodyPr wrap="square" lIns="0" tIns="0" rIns="0" bIns="0" rtlCol="0" anchor="ctr"/>
+          <a:lstStyle/>
+          <a:p>
+            <a:pPr indent="0" marL="0">
+              <a:buNone/>
+            </a:pPr>
+            <a:r>
+              <a:rPr lang="en-US" sz="1350" dirty="0">
+                <a:solidFill>
+                  <a:srgbClr val="A9C3B6"/>
+                </a:solidFill>
+                <a:latin typeface="Calibri" pitchFamily="34" charset="0"/>
+                <a:ea typeface="Calibri" pitchFamily="34" charset="-122"/>
+                <a:cs typeface="Calibri" pitchFamily="34" charset="-120"/>
+              </a:rPr>
+              <a:t>Gmail 서명 연동을 완료해 브랜드 서명이 자동 첨부되도록 설정</a:t>
+            </a:r>
+            <a:endParaRPr lang="en-US" sz="1350" dirty="0"/>
+          </a:p>
+        </p:txBody>
+      </p:sp>
+      <p:sp>
+        <p:nvSpPr>
+          <p:cNvPr id="9" name="Shape 7"/>
+          <p:cNvSpPr/>
+          <p:nvPr/>
+        </p:nvSpPr>
+        <p:spPr>
+          <a:xfrm>
+            <a:off x="685800" y="2971800"/>
+            <a:ext cx="10817352" cy="960120"/>
+          </a:xfrm>
+          <a:prstGeom prst="roundRect">
+            <a:avLst>
+              <a:gd name="adj" fmla="val 7619"/>
+            </a:avLst>
+          </a:prstGeom>
+          <a:solidFill>
+            <a:srgbClr val="15352A"/>
+          </a:solidFill>
+          <a:ln w="12700">
+            <a:solidFill>
+              <a:srgbClr val="15352A"/>
+            </a:solidFill>
+            <a:prstDash val="solid"/>
+          </a:ln>
+        </p:spPr>
+      </p:sp>
+      <p:sp>
+        <p:nvSpPr>
+          <p:cNvPr id="10" name="Shape 8"/>
+          <p:cNvSpPr/>
+          <p:nvPr/>
+        </p:nvSpPr>
+        <p:spPr>
+          <a:xfrm>
+            <a:off x="1005840" y="3227832"/>
+            <a:ext cx="438912" cy="438912"/>
+          </a:xfrm>
+          <a:prstGeom prst="ellipse">
+            <a:avLst/>
+          </a:prstGeom>
+          <a:solidFill>
+            <a:srgbClr val="00C878"/>
+          </a:solidFill>
+          <a:ln/>
+        </p:spPr>
+      </p:sp>
+      <p:sp>
+        <p:nvSpPr>
+          <p:cNvPr id="11" name="Text 9"/>
+          <p:cNvSpPr/>
+          <p:nvPr/>
+        </p:nvSpPr>
+        <p:spPr>
+          <a:xfrm>
+            <a:off x="1005840" y="3227832"/>
+            <a:ext cx="438912" cy="438912"/>
+          </a:xfrm>
+          <a:prstGeom prst="rect">
+            <a:avLst/>
+          </a:prstGeom>
+          <a:noFill/>
+          <a:ln/>
+        </p:spPr>
+        <p:txBody>
+          <a:bodyPr wrap="square" lIns="0" tIns="0" rIns="0" bIns="0" rtlCol="0" anchor="ctr"/>
+          <a:lstStyle/>
+          <a:p>
+            <a:pPr algn="ctr" indent="0" marL="0">
+              <a:buNone/>
+            </a:pPr>
+            <a:r>
+              <a:rPr lang="en-US" sz="1400" b="1" dirty="0">
+                <a:solidFill>
+                  <a:srgbClr val="FFFFFF"/>
+                </a:solidFill>
+                <a:latin typeface="Calibri" pitchFamily="34" charset="0"/>
+                <a:ea typeface="Calibri" pitchFamily="34" charset="-122"/>
+                <a:cs typeface="Calibri" pitchFamily="34" charset="-120"/>
+              </a:rPr>
+              <a:t>2</a:t>
+            </a:r>
+            <a:endParaRPr lang="en-US" sz="1400" dirty="0"/>
+          </a:p>
+        </p:txBody>
+      </p:sp>
+      <p:sp>
+        <p:nvSpPr>
+          <p:cNvPr id="12" name="Text 10"/>
+          <p:cNvSpPr/>
+          <p:nvPr/>
+        </p:nvSpPr>
+        <p:spPr>
+          <a:xfrm>
+            <a:off x="1645920" y="3099816"/>
+            <a:ext cx="3291840" cy="365760"/>
+          </a:xfrm>
+          <a:prstGeom prst="rect">
+            <a:avLst/>
+          </a:prstGeom>
+          <a:noFill/>
+          <a:ln/>
+        </p:spPr>
+        <p:txBody>
+          <a:bodyPr wrap="square" lIns="0" tIns="0" rIns="0" bIns="0" rtlCol="0" anchor="ctr"/>
+          <a:lstStyle/>
+          <a:p>
+            <a:pPr indent="0" marL="0">
+              <a:buNone/>
+            </a:pPr>
+            <a:r>
+              <a:rPr lang="en-US" sz="1700" b="1" dirty="0">
+                <a:solidFill>
+                  <a:srgbClr val="FFFFFF"/>
+                </a:solidFill>
+                <a:latin typeface="Calibri" pitchFamily="34" charset="0"/>
+                <a:ea typeface="Calibri" pitchFamily="34" charset="-122"/>
+                <a:cs typeface="Calibri" pitchFamily="34" charset="-120"/>
+              </a:rPr>
+              <a:t>운영 계정 이관 검토</a:t>
+            </a:r>
+            <a:endParaRPr lang="en-US" sz="1700" dirty="0"/>
+          </a:p>
+        </p:txBody>
+      </p:sp>
+      <p:sp>
+        <p:nvSpPr>
+          <p:cNvPr id="13" name="Text 11"/>
+          <p:cNvSpPr/>
+          <p:nvPr/>
+        </p:nvSpPr>
+        <p:spPr>
+          <a:xfrm>
+            <a:off x="5120640" y="3099816"/>
+            <a:ext cx="6062472" cy="704088"/>
+          </a:xfrm>
+          <a:prstGeom prst="rect">
+            <a:avLst/>
+          </a:prstGeom>
+          <a:noFill/>
+          <a:ln/>
+        </p:spPr>
+        <p:txBody>
+          <a:bodyPr wrap="square" lIns="0" tIns="0" rIns="0" bIns="0" rtlCol="0" anchor="ctr"/>
+          <a:lstStyle/>
+          <a:p>
+            <a:pPr indent="0" marL="0">
+              <a:buNone/>
+            </a:pPr>
+            <a:r>
+              <a:rPr lang="en-US" sz="1350" dirty="0">
+                <a:solidFill>
+                  <a:srgbClr val="A9C3B6"/>
+                </a:solidFill>
+                <a:latin typeface="Calibri" pitchFamily="34" charset="0"/>
+                <a:ea typeface="Calibri" pitchFamily="34" charset="-122"/>
+                <a:cs typeface="Calibri" pitchFamily="34" charset="-120"/>
+              </a:rPr>
+              <a:t>개인 계정 종속을 없애기 위해 팀 공용 계정 또는 담당자 계정으로 이전</a:t>
+            </a:r>
+            <a:endParaRPr lang="en-US" sz="1350" dirty="0"/>
+          </a:p>
+        </p:txBody>
+      </p:sp>
+      <p:sp>
+        <p:nvSpPr>
+          <p:cNvPr id="14" name="Shape 12"/>
+          <p:cNvSpPr/>
+          <p:nvPr/>
+        </p:nvSpPr>
+        <p:spPr>
+          <a:xfrm>
+            <a:off x="685800" y="4114800"/>
+            <a:ext cx="10817352" cy="960120"/>
+          </a:xfrm>
+          <a:prstGeom prst="roundRect">
+            <a:avLst>
+              <a:gd name="adj" fmla="val 7619"/>
+            </a:avLst>
+          </a:prstGeom>
+          <a:solidFill>
+            <a:srgbClr val="15352A"/>
+          </a:solidFill>
+          <a:ln w="12700">
+            <a:solidFill>
+              <a:srgbClr val="15352A"/>
+            </a:solidFill>
+            <a:prstDash val="solid"/>
+          </a:ln>
+        </p:spPr>
+      </p:sp>
+      <p:sp>
+        <p:nvSpPr>
+          <p:cNvPr id="15" name="Shape 13"/>
+          <p:cNvSpPr/>
+          <p:nvPr/>
+        </p:nvSpPr>
+        <p:spPr>
+          <a:xfrm>
+            <a:off x="1005840" y="4370832"/>
+            <a:ext cx="438912" cy="438912"/>
+          </a:xfrm>
+          <a:prstGeom prst="ellipse">
+            <a:avLst/>
+          </a:prstGeom>
+          <a:solidFill>
+            <a:srgbClr val="00C878"/>
+          </a:solidFill>
+          <a:ln/>
+        </p:spPr>
+      </p:sp>
+      <p:sp>
+        <p:nvSpPr>
+          <p:cNvPr id="16" name="Text 14"/>
+          <p:cNvSpPr/>
+          <p:nvPr/>
+        </p:nvSpPr>
+        <p:spPr>
+          <a:xfrm>
+            <a:off x="1005840" y="4370832"/>
+            <a:ext cx="438912" cy="438912"/>
+          </a:xfrm>
+          <a:prstGeom prst="rect">
+            <a:avLst/>
+          </a:prstGeom>
+          <a:noFill/>
+          <a:ln/>
+        </p:spPr>
+        <p:txBody>
+          <a:bodyPr wrap="square" lIns="0" tIns="0" rIns="0" bIns="0" rtlCol="0" anchor="ctr"/>
+          <a:lstStyle/>
+          <a:p>
+            <a:pPr algn="ctr" indent="0" marL="0">
+              <a:buNone/>
+            </a:pPr>
+            <a:r>
+              <a:rPr lang="en-US" sz="1400" b="1" dirty="0">
+                <a:solidFill>
+                  <a:srgbClr val="FFFFFF"/>
+                </a:solidFill>
+                <a:latin typeface="Calibri" pitchFamily="34" charset="0"/>
+                <a:ea typeface="Calibri" pitchFamily="34" charset="-122"/>
+                <a:cs typeface="Calibri" pitchFamily="34" charset="-120"/>
+              </a:rPr>
+              <a:t>3</a:t>
+            </a:r>
+            <a:endParaRPr lang="en-US" sz="1400" dirty="0"/>
+          </a:p>
+        </p:txBody>
+      </p:sp>
+      <p:sp>
+        <p:nvSpPr>
+          <p:cNvPr id="17" name="Text 15"/>
+          <p:cNvSpPr/>
+          <p:nvPr/>
+        </p:nvSpPr>
+        <p:spPr>
+          <a:xfrm>
+            <a:off x="1645920" y="4242816"/>
+            <a:ext cx="3291840" cy="365760"/>
+          </a:xfrm>
+          <a:prstGeom prst="rect">
+            <a:avLst/>
+          </a:prstGeom>
+          <a:noFill/>
+          <a:ln/>
+        </p:spPr>
+        <p:txBody>
+          <a:bodyPr wrap="square" lIns="0" tIns="0" rIns="0" bIns="0" rtlCol="0" anchor="ctr"/>
+          <a:lstStyle/>
+          <a:p>
+            <a:pPr indent="0" marL="0">
+              <a:buNone/>
+            </a:pPr>
+            <a:r>
+              <a:rPr lang="en-US" sz="1700" b="1" dirty="0">
+                <a:solidFill>
+                  <a:srgbClr val="FFFFFF"/>
+                </a:solidFill>
+                <a:latin typeface="Calibri" pitchFamily="34" charset="0"/>
+                <a:ea typeface="Calibri" pitchFamily="34" charset="-122"/>
+                <a:cs typeface="Calibri" pitchFamily="34" charset="-120"/>
+              </a:rPr>
+              <a:t>타 업무 확대 적용</a:t>
+            </a:r>
+            <a:endParaRPr lang="en-US" sz="1700" dirty="0"/>
+          </a:p>
+        </p:txBody>
+      </p:sp>
+      <p:sp>
+        <p:nvSpPr>
+          <p:cNvPr id="18" name="Text 16"/>
+          <p:cNvSpPr/>
+          <p:nvPr/>
+        </p:nvSpPr>
+        <p:spPr>
+          <a:xfrm>
+            <a:off x="5120640" y="4242816"/>
+            <a:ext cx="6062472" cy="704088"/>
+          </a:xfrm>
+          <a:prstGeom prst="rect">
+            <a:avLst/>
+          </a:prstGeom>
+          <a:noFill/>
+          <a:ln/>
+        </p:spPr>
+        <p:txBody>
+          <a:bodyPr wrap="square" lIns="0" tIns="0" rIns="0" bIns="0" rtlCol="0" anchor="ctr"/>
+          <a:lstStyle/>
+          <a:p>
+            <a:pPr indent="0" marL="0">
+              <a:buNone/>
+            </a:pPr>
+            <a:r>
+              <a:rPr lang="en-US" sz="1350" dirty="0">
+                <a:solidFill>
+                  <a:srgbClr val="A9C3B6"/>
+                </a:solidFill>
+                <a:latin typeface="Calibri" pitchFamily="34" charset="0"/>
+                <a:ea typeface="Calibri" pitchFamily="34" charset="-122"/>
+                <a:cs typeface="Calibri" pitchFamily="34" charset="-120"/>
+              </a:rPr>
+              <a:t>경조사 · 근속 축하 등 반복 안내 업무에 동일 구조 적용</a:t>
+            </a:r>
+            <a:endParaRPr lang="en-US" sz="1350" dirty="0"/>
+          </a:p>
+        </p:txBody>
+      </p:sp>
+      <p:sp>
+        <p:nvSpPr>
+          <p:cNvPr id="19" name="Text 17"/>
+          <p:cNvSpPr/>
+          <p:nvPr/>
+        </p:nvSpPr>
+        <p:spPr>
+          <a:xfrm>
+            <a:off x="685800" y="5669280"/>
+            <a:ext cx="5486400" cy="457200"/>
+          </a:xfrm>
+          <a:prstGeom prst="rect">
+            <a:avLst/>
+          </a:prstGeom>
+          <a:noFill/>
+          <a:ln/>
+        </p:spPr>
+        <p:txBody>
+          <a:bodyPr wrap="square" lIns="0" tIns="0" rIns="0" bIns="0" rtlCol="0" anchor="ctr"/>
+          <a:lstStyle/>
+          <a:p>
+            <a:pPr indent="0" marL="0">
+              <a:buNone/>
+            </a:pPr>
+            <a:r>
+              <a:rPr lang="en-US" sz="2200" b="1" dirty="0">
+                <a:solidFill>
+                  <a:srgbClr val="00C878"/>
+                </a:solidFill>
+                <a:latin typeface="Calibri" pitchFamily="34" charset="0"/>
+                <a:ea typeface="Calibri" pitchFamily="34" charset="-122"/>
+                <a:cs typeface="Calibri" pitchFamily="34" charset="-120"/>
+              </a:rPr>
+              <a:t>감사합니다</a:t>
+            </a:r>
+            <a:endParaRPr lang="en-US" sz="2200" dirty="0"/>
           </a:p>
         </p:txBody>
       </p:sp>
@@ -6379,7 +7131,7 @@
                 <a:ea typeface="Calibri" pitchFamily="34" charset="-122"/>
                 <a:cs typeface="Calibri" pitchFamily="34" charset="-120"/>
               </a:rPr>
-              <a:t>지속가능한 운영 구조</a:t>
+              <a:t>2026년 8월 운영 결과</a:t>
             </a:r>
             <a:endParaRPr lang="en-US" sz="3800" dirty="0"/>
           </a:p>
@@ -6418,7 +7170,7 @@
                 <a:ea typeface="Calibri" pitchFamily="34" charset="-122"/>
                 <a:cs typeface="Calibri" pitchFamily="34" charset="-120"/>
               </a:rPr>
-              <a:t>후임자가 코드를 몰라도 계속 쓸 수 있도록 설계했습니다</a:t>
+              <a:t>실제 발송까지 완료했습니다</a:t>
             </a:r>
             <a:endParaRPr lang="en-US" sz="1400" dirty="0"/>
           </a:p>
@@ -6433,11 +7185,11 @@
         <p:spPr>
           <a:xfrm>
             <a:off x="685800" y="1783080"/>
-            <a:ext cx="10817352" cy="1115568"/>
+            <a:ext cx="3331464" cy="1691640"/>
           </a:xfrm>
           <a:prstGeom prst="roundRect">
             <a:avLst>
-              <a:gd name="adj" fmla="val 6557"/>
+              <a:gd name="adj" fmla="val 4324"/>
             </a:avLst>
           </a:prstGeom>
           <a:solidFill>
@@ -6453,23 +7205,42 @@
       </p:sp>
       <p:sp>
         <p:nvSpPr>
-          <p:cNvPr id="5" name="Shape 3"/>
-          <p:cNvSpPr/>
-          <p:nvPr/>
-        </p:nvSpPr>
-        <p:spPr>
-          <a:xfrm>
-            <a:off x="1005840" y="2112264"/>
-            <a:ext cx="457200" cy="457200"/>
-          </a:xfrm>
-          <a:prstGeom prst="ellipse">
-            <a:avLst/>
-          </a:prstGeom>
-          <a:solidFill>
-            <a:srgbClr val="00C878"/>
-          </a:solidFill>
-          <a:ln/>
-        </p:spPr>
+          <p:cNvPr id="5" name="Text 3"/>
+          <p:cNvSpPr/>
+          <p:nvPr/>
+        </p:nvSpPr>
+        <p:spPr>
+          <a:xfrm>
+            <a:off x="960120" y="2011680"/>
+            <a:ext cx="2782824" cy="868680"/>
+          </a:xfrm>
+          <a:prstGeom prst="rect">
+            <a:avLst/>
+          </a:prstGeom>
+          <a:noFill/>
+          <a:ln/>
+        </p:spPr>
+        <p:txBody>
+          <a:bodyPr wrap="square" lIns="0" tIns="0" rIns="0" bIns="0" rtlCol="0" anchor="ctr"/>
+          <a:lstStyle/>
+          <a:p>
+            <a:pPr indent="0" marL="0">
+              <a:buNone/>
+            </a:pPr>
+            <a:r>
+              <a:rPr lang="en-US" sz="5400" b="1" dirty="0">
+                <a:solidFill>
+                  <a:srgbClr val="15211D"/>
+                </a:solidFill>
+                <a:latin typeface="Calibri" pitchFamily="34" charset="0"/>
+                <a:ea typeface="Calibri" pitchFamily="34" charset="-122"/>
+                <a:cs typeface="Calibri" pitchFamily="34" charset="-120"/>
+              </a:rPr>
+              <a:t>15</a:t>
+            </a:r>
+            <a:endParaRPr lang="en-US" sz="5400" dirty="0"/>
+          </a:p>
+        </p:txBody>
       </p:sp>
       <p:sp>
         <p:nvSpPr>
@@ -6479,32 +7250,32 @@
         </p:nvSpPr>
         <p:spPr>
           <a:xfrm>
-            <a:off x="1005840" y="2112264"/>
-            <a:ext cx="457200" cy="457200"/>
-          </a:xfrm>
-          <a:prstGeom prst="rect">
-            <a:avLst/>
-          </a:prstGeom>
-          <a:noFill/>
-          <a:ln/>
-        </p:spPr>
-        <p:txBody>
-          <a:bodyPr wrap="square" lIns="0" tIns="0" rIns="0" bIns="0" rtlCol="0" anchor="ctr"/>
-          <a:lstStyle/>
-          <a:p>
-            <a:pPr algn="ctr" indent="0" marL="0">
-              <a:buNone/>
-            </a:pPr>
-            <a:r>
-              <a:rPr lang="en-US" sz="1400" b="1" dirty="0">
-                <a:solidFill>
-                  <a:srgbClr val="FFFFFF"/>
-                </a:solidFill>
-                <a:latin typeface="Calibri" pitchFamily="34" charset="0"/>
-                <a:ea typeface="Calibri" pitchFamily="34" charset="-122"/>
-                <a:cs typeface="Calibri" pitchFamily="34" charset="-120"/>
-              </a:rPr>
-              <a:t>1</a:t>
+            <a:off x="960120" y="2907792"/>
+            <a:ext cx="2782824" cy="320040"/>
+          </a:xfrm>
+          <a:prstGeom prst="rect">
+            <a:avLst/>
+          </a:prstGeom>
+          <a:noFill/>
+          <a:ln/>
+        </p:spPr>
+        <p:txBody>
+          <a:bodyPr wrap="square" lIns="0" tIns="0" rIns="0" bIns="0" rtlCol="0" anchor="ctr"/>
+          <a:lstStyle/>
+          <a:p>
+            <a:pPr indent="0" marL="0">
+              <a:buNone/>
+            </a:pPr>
+            <a:r>
+              <a:rPr lang="en-US" sz="1400" dirty="0">
+                <a:solidFill>
+                  <a:srgbClr val="5F7069"/>
+                </a:solidFill>
+                <a:latin typeface="Calibri" pitchFamily="34" charset="0"/>
+                <a:ea typeface="Calibri" pitchFamily="34" charset="-122"/>
+                <a:cs typeface="Calibri" pitchFamily="34" charset="-120"/>
+              </a:rPr>
+              <a:t>8월 안내 대상자</a:t>
             </a:r>
             <a:endParaRPr lang="en-US" sz="1400" dirty="0"/>
           </a:p>
@@ -6512,113 +7283,123 @@
       </p:sp>
       <p:sp>
         <p:nvSpPr>
-          <p:cNvPr id="7" name="Text 5"/>
-          <p:cNvSpPr/>
-          <p:nvPr/>
-        </p:nvSpPr>
-        <p:spPr>
-          <a:xfrm>
-            <a:off x="1645920" y="1984248"/>
-            <a:ext cx="2468880" cy="384048"/>
-          </a:xfrm>
-          <a:prstGeom prst="rect">
-            <a:avLst/>
-          </a:prstGeom>
-          <a:noFill/>
-          <a:ln/>
-        </p:spPr>
-        <p:txBody>
-          <a:bodyPr wrap="square" lIns="0" tIns="0" rIns="0" bIns="0" rtlCol="0" anchor="ctr"/>
-          <a:lstStyle/>
-          <a:p>
-            <a:pPr indent="0" marL="0">
-              <a:buNone/>
-            </a:pPr>
-            <a:r>
-              <a:rPr lang="en-US" sz="1900" b="1" dirty="0">
-                <a:solidFill>
-                  <a:srgbClr val="15211D"/>
-                </a:solidFill>
-                <a:latin typeface="Calibri" pitchFamily="34" charset="0"/>
-                <a:ea typeface="Calibri" pitchFamily="34" charset="-122"/>
-                <a:cs typeface="Calibri" pitchFamily="34" charset="-120"/>
-              </a:rPr>
-              <a:t>설정 시트</a:t>
-            </a:r>
-            <a:endParaRPr lang="en-US" sz="1900" dirty="0"/>
-          </a:p>
-        </p:txBody>
-      </p:sp>
-      <p:sp>
-        <p:nvSpPr>
-          <p:cNvPr id="8" name="Text 6"/>
-          <p:cNvSpPr/>
-          <p:nvPr/>
-        </p:nvSpPr>
-        <p:spPr>
-          <a:xfrm>
-            <a:off x="4297680" y="1947672"/>
-            <a:ext cx="6885432" cy="804672"/>
-          </a:xfrm>
-          <a:prstGeom prst="rect">
-            <a:avLst/>
-          </a:prstGeom>
-          <a:noFill/>
-          <a:ln/>
-        </p:spPr>
-        <p:txBody>
-          <a:bodyPr wrap="square" lIns="0" tIns="0" rIns="0" bIns="0" rtlCol="0" anchor="ctr"/>
-          <a:lstStyle/>
-          <a:p>
-            <a:pPr indent="0" marL="0">
-              <a:buNone/>
-            </a:pPr>
-            <a:r>
-              <a:rPr lang="en-US" sz="1350" dirty="0">
-                <a:solidFill>
-                  <a:srgbClr val="5F7069"/>
-                </a:solidFill>
-                <a:latin typeface="Calibri" pitchFamily="34" charset="0"/>
-                <a:ea typeface="Calibri" pitchFamily="34" charset="-122"/>
-                <a:cs typeface="Calibri" pitchFamily="34" charset="-120"/>
-              </a:rPr>
-              <a:t>메일 제목 · 본문 · 제외 규칙 · 발신자명을 스프레드시트에서 직접 수정.</a:t>
-            </a:r>
-            <a:endParaRPr lang="en-US" sz="1350" dirty="0"/>
-          </a:p>
-          <a:p>
-            <a:pPr indent="0" marL="0">
-              <a:buNone/>
-            </a:pPr>
-            <a:r>
-              <a:rPr lang="en-US" sz="1350" dirty="0">
-                <a:solidFill>
-                  <a:srgbClr val="5F7069"/>
-                </a:solidFill>
-                <a:latin typeface="Calibri" pitchFamily="34" charset="0"/>
-                <a:ea typeface="Calibri" pitchFamily="34" charset="-122"/>
-                <a:cs typeface="Calibri" pitchFamily="34" charset="-120"/>
-              </a:rPr>
-              <a:t>코드를 열 필요가 없습니다.</a:t>
-            </a:r>
-            <a:endParaRPr lang="en-US" sz="1350" dirty="0"/>
-          </a:p>
-        </p:txBody>
-      </p:sp>
-      <p:sp>
-        <p:nvSpPr>
-          <p:cNvPr id="9" name="Shape 7"/>
-          <p:cNvSpPr/>
-          <p:nvPr/>
-        </p:nvSpPr>
-        <p:spPr>
-          <a:xfrm>
-            <a:off x="685800" y="3081528"/>
-            <a:ext cx="10817352" cy="1115568"/>
+          <p:cNvPr id="7" name="Shape 5"/>
+          <p:cNvSpPr/>
+          <p:nvPr/>
+        </p:nvSpPr>
+        <p:spPr>
+          <a:xfrm>
+            <a:off x="4428744" y="1783080"/>
+            <a:ext cx="3331464" cy="1691640"/>
           </a:xfrm>
           <a:prstGeom prst="roundRect">
             <a:avLst>
-              <a:gd name="adj" fmla="val 6557"/>
+              <a:gd name="adj" fmla="val 4324"/>
+            </a:avLst>
+          </a:prstGeom>
+          <a:solidFill>
+            <a:srgbClr val="0E2A22"/>
+          </a:solidFill>
+          <a:ln w="12700">
+            <a:solidFill>
+              <a:srgbClr val="0E2A22"/>
+            </a:solidFill>
+            <a:prstDash val="solid"/>
+          </a:ln>
+        </p:spPr>
+      </p:sp>
+      <p:sp>
+        <p:nvSpPr>
+          <p:cNvPr id="8" name="Text 6"/>
+          <p:cNvSpPr/>
+          <p:nvPr/>
+        </p:nvSpPr>
+        <p:spPr>
+          <a:xfrm>
+            <a:off x="4703064" y="2011680"/>
+            <a:ext cx="2782824" cy="868680"/>
+          </a:xfrm>
+          <a:prstGeom prst="rect">
+            <a:avLst/>
+          </a:prstGeom>
+          <a:noFill/>
+          <a:ln/>
+        </p:spPr>
+        <p:txBody>
+          <a:bodyPr wrap="square" lIns="0" tIns="0" rIns="0" bIns="0" rtlCol="0" anchor="ctr"/>
+          <a:lstStyle/>
+          <a:p>
+            <a:pPr indent="0" marL="0">
+              <a:buNone/>
+            </a:pPr>
+            <a:r>
+              <a:rPr lang="en-US" sz="5400" b="1" dirty="0">
+                <a:solidFill>
+                  <a:srgbClr val="00C878"/>
+                </a:solidFill>
+                <a:latin typeface="Calibri" pitchFamily="34" charset="0"/>
+                <a:ea typeface="Calibri" pitchFamily="34" charset="-122"/>
+                <a:cs typeface="Calibri" pitchFamily="34" charset="-120"/>
+              </a:rPr>
+              <a:t>15</a:t>
+            </a:r>
+            <a:endParaRPr lang="en-US" sz="5400" dirty="0"/>
+          </a:p>
+        </p:txBody>
+      </p:sp>
+      <p:sp>
+        <p:nvSpPr>
+          <p:cNvPr id="9" name="Text 7"/>
+          <p:cNvSpPr/>
+          <p:nvPr/>
+        </p:nvSpPr>
+        <p:spPr>
+          <a:xfrm>
+            <a:off x="4703064" y="2907792"/>
+            <a:ext cx="2782824" cy="320040"/>
+          </a:xfrm>
+          <a:prstGeom prst="rect">
+            <a:avLst/>
+          </a:prstGeom>
+          <a:noFill/>
+          <a:ln/>
+        </p:spPr>
+        <p:txBody>
+          <a:bodyPr wrap="square" lIns="0" tIns="0" rIns="0" bIns="0" rtlCol="0" anchor="ctr"/>
+          <a:lstStyle/>
+          <a:p>
+            <a:pPr indent="0" marL="0">
+              <a:buNone/>
+            </a:pPr>
+            <a:r>
+              <a:rPr lang="en-US" sz="1400" dirty="0">
+                <a:solidFill>
+                  <a:srgbClr val="B8CFC4"/>
+                </a:solidFill>
+                <a:latin typeface="Calibri" pitchFamily="34" charset="0"/>
+                <a:ea typeface="Calibri" pitchFamily="34" charset="-122"/>
+                <a:cs typeface="Calibri" pitchFamily="34" charset="-120"/>
+              </a:rPr>
+              <a:t>발송 완료</a:t>
+            </a:r>
+            <a:endParaRPr lang="en-US" sz="1400" dirty="0"/>
+          </a:p>
+        </p:txBody>
+      </p:sp>
+      <p:sp>
+        <p:nvSpPr>
+          <p:cNvPr id="10" name="Shape 8"/>
+          <p:cNvSpPr/>
+          <p:nvPr/>
+        </p:nvSpPr>
+        <p:spPr>
+          <a:xfrm>
+            <a:off x="8171688" y="1783080"/>
+            <a:ext cx="3331464" cy="1691640"/>
+          </a:xfrm>
+          <a:prstGeom prst="roundRect">
+            <a:avLst>
+              <a:gd name="adj" fmla="val 4324"/>
             </a:avLst>
           </a:prstGeom>
           <a:solidFill>
@@ -6634,14 +7415,131 @@
       </p:sp>
       <p:sp>
         <p:nvSpPr>
-          <p:cNvPr id="10" name="Shape 8"/>
-          <p:cNvSpPr/>
-          <p:nvPr/>
-        </p:nvSpPr>
-        <p:spPr>
-          <a:xfrm>
-            <a:off x="1005840" y="3410712"/>
-            <a:ext cx="457200" cy="457200"/>
+          <p:cNvPr id="11" name="Text 9"/>
+          <p:cNvSpPr/>
+          <p:nvPr/>
+        </p:nvSpPr>
+        <p:spPr>
+          <a:xfrm>
+            <a:off x="8446008" y="2011680"/>
+            <a:ext cx="2782824" cy="868680"/>
+          </a:xfrm>
+          <a:prstGeom prst="rect">
+            <a:avLst/>
+          </a:prstGeom>
+          <a:noFill/>
+          <a:ln/>
+        </p:spPr>
+        <p:txBody>
+          <a:bodyPr wrap="square" lIns="0" tIns="0" rIns="0" bIns="0" rtlCol="0" anchor="ctr"/>
+          <a:lstStyle/>
+          <a:p>
+            <a:pPr indent="0" marL="0">
+              <a:buNone/>
+            </a:pPr>
+            <a:r>
+              <a:rPr lang="en-US" sz="5400" b="1" dirty="0">
+                <a:solidFill>
+                  <a:srgbClr val="00C878"/>
+                </a:solidFill>
+                <a:latin typeface="Calibri" pitchFamily="34" charset="0"/>
+                <a:ea typeface="Calibri" pitchFamily="34" charset="-122"/>
+                <a:cs typeface="Calibri" pitchFamily="34" charset="-120"/>
+              </a:rPr>
+              <a:t>0</a:t>
+            </a:r>
+            <a:endParaRPr lang="en-US" sz="5400" dirty="0"/>
+          </a:p>
+        </p:txBody>
+      </p:sp>
+      <p:sp>
+        <p:nvSpPr>
+          <p:cNvPr id="12" name="Text 10"/>
+          <p:cNvSpPr/>
+          <p:nvPr/>
+        </p:nvSpPr>
+        <p:spPr>
+          <a:xfrm>
+            <a:off x="8446008" y="2907792"/>
+            <a:ext cx="2782824" cy="320040"/>
+          </a:xfrm>
+          <a:prstGeom prst="rect">
+            <a:avLst/>
+          </a:prstGeom>
+          <a:noFill/>
+          <a:ln/>
+        </p:spPr>
+        <p:txBody>
+          <a:bodyPr wrap="square" lIns="0" tIns="0" rIns="0" bIns="0" rtlCol="0" anchor="ctr"/>
+          <a:lstStyle/>
+          <a:p>
+            <a:pPr indent="0" marL="0">
+              <a:buNone/>
+            </a:pPr>
+            <a:r>
+              <a:rPr lang="en-US" sz="1400" dirty="0">
+                <a:solidFill>
+                  <a:srgbClr val="5F7069"/>
+                </a:solidFill>
+                <a:latin typeface="Calibri" pitchFamily="34" charset="0"/>
+                <a:ea typeface="Calibri" pitchFamily="34" charset="-122"/>
+                <a:cs typeface="Calibri" pitchFamily="34" charset="-120"/>
+              </a:rPr>
+              <a:t>누락 · 오발송</a:t>
+            </a:r>
+            <a:endParaRPr lang="en-US" sz="1400" dirty="0"/>
+          </a:p>
+        </p:txBody>
+      </p:sp>
+      <p:sp>
+        <p:nvSpPr>
+          <p:cNvPr id="13" name="Text 11"/>
+          <p:cNvSpPr/>
+          <p:nvPr/>
+        </p:nvSpPr>
+        <p:spPr>
+          <a:xfrm>
+            <a:off x="685800" y="3749040"/>
+            <a:ext cx="10817352" cy="347472"/>
+          </a:xfrm>
+          <a:prstGeom prst="rect">
+            <a:avLst/>
+          </a:prstGeom>
+          <a:noFill/>
+          <a:ln/>
+        </p:spPr>
+        <p:txBody>
+          <a:bodyPr wrap="square" lIns="0" tIns="0" rIns="0" bIns="0" rtlCol="0" anchor="ctr"/>
+          <a:lstStyle/>
+          <a:p>
+            <a:pPr indent="0" marL="0">
+              <a:buNone/>
+            </a:pPr>
+            <a:r>
+              <a:rPr lang="en-US" sz="1600" b="1" dirty="0">
+                <a:solidFill>
+                  <a:srgbClr val="15211D"/>
+                </a:solidFill>
+                <a:latin typeface="Calibri" pitchFamily="34" charset="0"/>
+                <a:ea typeface="Calibri" pitchFamily="34" charset="-122"/>
+                <a:cs typeface="Calibri" pitchFamily="34" charset="-120"/>
+              </a:rPr>
+              <a:t>이번 운영에서 확인된 것</a:t>
+            </a:r>
+            <a:endParaRPr lang="en-US" sz="1600" dirty="0"/>
+          </a:p>
+        </p:txBody>
+      </p:sp>
+      <p:sp>
+        <p:nvSpPr>
+          <p:cNvPr id="14" name="Shape 12"/>
+          <p:cNvSpPr/>
+          <p:nvPr/>
+        </p:nvSpPr>
+        <p:spPr>
+          <a:xfrm>
+            <a:off x="731520" y="4233672"/>
+            <a:ext cx="310896" cy="310896"/>
           </a:xfrm>
           <a:prstGeom prst="ellipse">
             <a:avLst/>
@@ -6654,14 +7552,14 @@
       </p:sp>
       <p:sp>
         <p:nvSpPr>
-          <p:cNvPr id="11" name="Text 9"/>
-          <p:cNvSpPr/>
-          <p:nvPr/>
-        </p:nvSpPr>
-        <p:spPr>
-          <a:xfrm>
-            <a:off x="1005840" y="3410712"/>
-            <a:ext cx="457200" cy="457200"/>
+          <p:cNvPr id="15" name="Text 13"/>
+          <p:cNvSpPr/>
+          <p:nvPr/>
+        </p:nvSpPr>
+        <p:spPr>
+          <a:xfrm>
+            <a:off x="731520" y="4233672"/>
+            <a:ext cx="310896" cy="310896"/>
           </a:xfrm>
           <a:prstGeom prst="rect">
             <a:avLst/>
@@ -6677,7 +7575,7 @@
               <a:buNone/>
             </a:pPr>
             <a:r>
-              <a:rPr lang="en-US" sz="1400" b="1" dirty="0">
+              <a:rPr lang="en-US" sz="1300" b="1" dirty="0">
                 <a:solidFill>
                   <a:srgbClr val="FFFFFF"/>
                 </a:solidFill>
@@ -6685,7 +7583,46 @@
                 <a:ea typeface="Calibri" pitchFamily="34" charset="-122"/>
                 <a:cs typeface="Calibri" pitchFamily="34" charset="-120"/>
               </a:rPr>
-              <a:t>2</a:t>
+              <a:t>v</a:t>
+            </a:r>
+            <a:endParaRPr lang="en-US" sz="1300" dirty="0"/>
+          </a:p>
+        </p:txBody>
+      </p:sp>
+      <p:sp>
+        <p:nvSpPr>
+          <p:cNvPr id="16" name="Text 14"/>
+          <p:cNvSpPr/>
+          <p:nvPr/>
+        </p:nvSpPr>
+        <p:spPr>
+          <a:xfrm>
+            <a:off x="1252728" y="4187952"/>
+            <a:ext cx="10177272" cy="411480"/>
+          </a:xfrm>
+          <a:prstGeom prst="rect">
+            <a:avLst/>
+          </a:prstGeom>
+          <a:noFill/>
+          <a:ln/>
+        </p:spPr>
+        <p:txBody>
+          <a:bodyPr wrap="square" lIns="0" tIns="0" rIns="0" bIns="0" rtlCol="0" anchor="ctr"/>
+          <a:lstStyle/>
+          <a:p>
+            <a:pPr indent="0" marL="0">
+              <a:buNone/>
+            </a:pPr>
+            <a:r>
+              <a:rPr lang="en-US" sz="1400" dirty="0">
+                <a:solidFill>
+                  <a:srgbClr val="15211D"/>
+                </a:solidFill>
+                <a:latin typeface="Calibri" pitchFamily="34" charset="0"/>
+                <a:ea typeface="Calibri" pitchFamily="34" charset="-122"/>
+                <a:cs typeface="Calibri" pitchFamily="34" charset="-120"/>
+              </a:rPr>
+              <a:t>휴직자 1명이 규칙에 따라 자동으로 비대상 처리되어, 잘못된 발송이 발생하지 않았습니다.</a:t>
             </a:r>
             <a:endParaRPr lang="en-US" sz="1400" dirty="0"/>
           </a:p>
@@ -6693,136 +7630,14 @@
       </p:sp>
       <p:sp>
         <p:nvSpPr>
-          <p:cNvPr id="12" name="Text 10"/>
-          <p:cNvSpPr/>
-          <p:nvPr/>
-        </p:nvSpPr>
-        <p:spPr>
-          <a:xfrm>
-            <a:off x="1645920" y="3282696"/>
-            <a:ext cx="2468880" cy="384048"/>
-          </a:xfrm>
-          <a:prstGeom prst="rect">
-            <a:avLst/>
-          </a:prstGeom>
-          <a:noFill/>
-          <a:ln/>
-        </p:spPr>
-        <p:txBody>
-          <a:bodyPr wrap="square" lIns="0" tIns="0" rIns="0" bIns="0" rtlCol="0" anchor="ctr"/>
-          <a:lstStyle/>
-          <a:p>
-            <a:pPr indent="0" marL="0">
-              <a:buNone/>
-            </a:pPr>
-            <a:r>
-              <a:rPr lang="en-US" sz="1900" b="1" dirty="0">
-                <a:solidFill>
-                  <a:srgbClr val="15211D"/>
-                </a:solidFill>
-                <a:latin typeface="Calibri" pitchFamily="34" charset="0"/>
-                <a:ea typeface="Calibri" pitchFamily="34" charset="-122"/>
-                <a:cs typeface="Calibri" pitchFamily="34" charset="-120"/>
-              </a:rPr>
-              <a:t>사용법 시트</a:t>
-            </a:r>
-            <a:endParaRPr lang="en-US" sz="1900" dirty="0"/>
-          </a:p>
-        </p:txBody>
-      </p:sp>
-      <p:sp>
-        <p:nvSpPr>
-          <p:cNvPr id="13" name="Text 11"/>
-          <p:cNvSpPr/>
-          <p:nvPr/>
-        </p:nvSpPr>
-        <p:spPr>
-          <a:xfrm>
-            <a:off x="4297680" y="3246120"/>
-            <a:ext cx="6885432" cy="804672"/>
-          </a:xfrm>
-          <a:prstGeom prst="rect">
-            <a:avLst/>
-          </a:prstGeom>
-          <a:noFill/>
-          <a:ln/>
-        </p:spPr>
-        <p:txBody>
-          <a:bodyPr wrap="square" lIns="0" tIns="0" rIns="0" bIns="0" rtlCol="0" anchor="ctr"/>
-          <a:lstStyle/>
-          <a:p>
-            <a:pPr indent="0" marL="0">
-              <a:buNone/>
-            </a:pPr>
-            <a:r>
-              <a:rPr lang="en-US" sz="1350" dirty="0">
-                <a:solidFill>
-                  <a:srgbClr val="5F7069"/>
-                </a:solidFill>
-                <a:latin typeface="Calibri" pitchFamily="34" charset="0"/>
-                <a:ea typeface="Calibri" pitchFamily="34" charset="-122"/>
-                <a:cs typeface="Calibri" pitchFamily="34" charset="-120"/>
-              </a:rPr>
-              <a:t>매월 작업 순서와 문제 해결 방법을 스프레드시트 안에 문서로 내장.</a:t>
-            </a:r>
-            <a:endParaRPr lang="en-US" sz="1350" dirty="0"/>
-          </a:p>
-          <a:p>
-            <a:pPr indent="0" marL="0">
-              <a:buNone/>
-            </a:pPr>
-            <a:r>
-              <a:rPr lang="en-US" sz="1350" dirty="0">
-                <a:solidFill>
-                  <a:srgbClr val="5F7069"/>
-                </a:solidFill>
-                <a:latin typeface="Calibri" pitchFamily="34" charset="0"/>
-                <a:ea typeface="Calibri" pitchFamily="34" charset="-122"/>
-                <a:cs typeface="Calibri" pitchFamily="34" charset="-120"/>
-              </a:rPr>
-              <a:t>별도 매뉴얼 관리가 불필요합니다.</a:t>
-            </a:r>
-            <a:endParaRPr lang="en-US" sz="1350" dirty="0"/>
-          </a:p>
-        </p:txBody>
-      </p:sp>
-      <p:sp>
-        <p:nvSpPr>
-          <p:cNvPr id="14" name="Shape 12"/>
-          <p:cNvSpPr/>
-          <p:nvPr/>
-        </p:nvSpPr>
-        <p:spPr>
-          <a:xfrm>
-            <a:off x="685800" y="4379976"/>
-            <a:ext cx="10817352" cy="1115568"/>
-          </a:xfrm>
-          <a:prstGeom prst="roundRect">
-            <a:avLst>
-              <a:gd name="adj" fmla="val 6557"/>
-            </a:avLst>
-          </a:prstGeom>
-          <a:solidFill>
-            <a:srgbClr val="F1F6F3"/>
-          </a:solidFill>
-          <a:ln w="12700">
-            <a:solidFill>
-              <a:srgbClr val="F1F6F3"/>
-            </a:solidFill>
-            <a:prstDash val="solid"/>
-          </a:ln>
-        </p:spPr>
-      </p:sp>
-      <p:sp>
-        <p:nvSpPr>
-          <p:cNvPr id="15" name="Shape 13"/>
-          <p:cNvSpPr/>
-          <p:nvPr/>
-        </p:nvSpPr>
-        <p:spPr>
-          <a:xfrm>
-            <a:off x="1005840" y="4709160"/>
-            <a:ext cx="457200" cy="457200"/>
+          <p:cNvPr id="17" name="Shape 15"/>
+          <p:cNvSpPr/>
+          <p:nvPr/>
+        </p:nvSpPr>
+        <p:spPr>
+          <a:xfrm>
+            <a:off x="731520" y="4800600"/>
+            <a:ext cx="310896" cy="310896"/>
           </a:xfrm>
           <a:prstGeom prst="ellipse">
             <a:avLst/>
@@ -6835,14 +7650,14 @@
       </p:sp>
       <p:sp>
         <p:nvSpPr>
-          <p:cNvPr id="16" name="Text 14"/>
-          <p:cNvSpPr/>
-          <p:nvPr/>
-        </p:nvSpPr>
-        <p:spPr>
-          <a:xfrm>
-            <a:off x="1005840" y="4709160"/>
-            <a:ext cx="457200" cy="457200"/>
+          <p:cNvPr id="18" name="Text 16"/>
+          <p:cNvSpPr/>
+          <p:nvPr/>
+        </p:nvSpPr>
+        <p:spPr>
+          <a:xfrm>
+            <a:off x="731520" y="4800600"/>
+            <a:ext cx="310896" cy="310896"/>
           </a:xfrm>
           <a:prstGeom prst="rect">
             <a:avLst/>
@@ -6858,7 +7673,7 @@
               <a:buNone/>
             </a:pPr>
             <a:r>
-              <a:rPr lang="en-US" sz="1400" b="1" dirty="0">
+              <a:rPr lang="en-US" sz="1300" b="1" dirty="0">
                 <a:solidFill>
                   <a:srgbClr val="FFFFFF"/>
                 </a:solidFill>
@@ -6866,7 +7681,46 @@
                 <a:ea typeface="Calibri" pitchFamily="34" charset="-122"/>
                 <a:cs typeface="Calibri" pitchFamily="34" charset="-120"/>
               </a:rPr>
-              <a:t>3</a:t>
+              <a:t>v</a:t>
+            </a:r>
+            <a:endParaRPr lang="en-US" sz="1300" dirty="0"/>
+          </a:p>
+        </p:txBody>
+      </p:sp>
+      <p:sp>
+        <p:nvSpPr>
+          <p:cNvPr id="19" name="Text 17"/>
+          <p:cNvSpPr/>
+          <p:nvPr/>
+        </p:nvSpPr>
+        <p:spPr>
+          <a:xfrm>
+            <a:off x="1252728" y="4754880"/>
+            <a:ext cx="10177272" cy="411480"/>
+          </a:xfrm>
+          <a:prstGeom prst="rect">
+            <a:avLst/>
+          </a:prstGeom>
+          <a:noFill/>
+          <a:ln/>
+        </p:spPr>
+        <p:txBody>
+          <a:bodyPr wrap="square" lIns="0" tIns="0" rIns="0" bIns="0" rtlCol="0" anchor="ctr"/>
+          <a:lstStyle/>
+          <a:p>
+            <a:pPr indent="0" marL="0">
+              <a:buNone/>
+            </a:pPr>
+            <a:r>
+              <a:rPr lang="en-US" sz="1400" dirty="0">
+                <a:solidFill>
+                  <a:srgbClr val="15211D"/>
+                </a:solidFill>
+                <a:latin typeface="Calibri" pitchFamily="34" charset="0"/>
+                <a:ea typeface="Calibri" pitchFamily="34" charset="-122"/>
+                <a:cs typeface="Calibri" pitchFamily="34" charset="-120"/>
+              </a:rPr>
+              <a:t>이메일 주소를 개별로 조회하지 않고, 명단에 있는 정보만으로 15명 전원에게 발송했습니다.</a:t>
             </a:r>
             <a:endParaRPr lang="en-US" sz="1400" dirty="0"/>
           </a:p>
@@ -6874,30 +7728,89 @@
       </p:sp>
       <p:sp>
         <p:nvSpPr>
-          <p:cNvPr id="17" name="Text 15"/>
-          <p:cNvSpPr/>
-          <p:nvPr/>
-        </p:nvSpPr>
-        <p:spPr>
-          <a:xfrm>
-            <a:off x="1645920" y="4581144"/>
-            <a:ext cx="2468880" cy="384048"/>
-          </a:xfrm>
-          <a:prstGeom prst="rect">
-            <a:avLst/>
-          </a:prstGeom>
-          <a:noFill/>
-          <a:ln/>
-        </p:spPr>
-        <p:txBody>
-          <a:bodyPr wrap="square" lIns="0" tIns="0" rIns="0" bIns="0" rtlCol="0" anchor="ctr"/>
-          <a:lstStyle/>
-          <a:p>
-            <a:pPr indent="0" marL="0">
-              <a:buNone/>
-            </a:pPr>
-            <a:r>
-              <a:rPr lang="en-US" sz="1900" b="1" dirty="0">
+          <p:cNvPr id="20" name="Shape 18"/>
+          <p:cNvSpPr/>
+          <p:nvPr/>
+        </p:nvSpPr>
+        <p:spPr>
+          <a:xfrm>
+            <a:off x="731520" y="5367528"/>
+            <a:ext cx="310896" cy="310896"/>
+          </a:xfrm>
+          <a:prstGeom prst="ellipse">
+            <a:avLst/>
+          </a:prstGeom>
+          <a:solidFill>
+            <a:srgbClr val="00C878"/>
+          </a:solidFill>
+          <a:ln/>
+        </p:spPr>
+      </p:sp>
+      <p:sp>
+        <p:nvSpPr>
+          <p:cNvPr id="21" name="Text 19"/>
+          <p:cNvSpPr/>
+          <p:nvPr/>
+        </p:nvSpPr>
+        <p:spPr>
+          <a:xfrm>
+            <a:off x="731520" y="5367528"/>
+            <a:ext cx="310896" cy="310896"/>
+          </a:xfrm>
+          <a:prstGeom prst="rect">
+            <a:avLst/>
+          </a:prstGeom>
+          <a:noFill/>
+          <a:ln/>
+        </p:spPr>
+        <p:txBody>
+          <a:bodyPr wrap="square" lIns="0" tIns="0" rIns="0" bIns="0" rtlCol="0" anchor="ctr"/>
+          <a:lstStyle/>
+          <a:p>
+            <a:pPr algn="ctr" indent="0" marL="0">
+              <a:buNone/>
+            </a:pPr>
+            <a:r>
+              <a:rPr lang="en-US" sz="1300" b="1" dirty="0">
+                <a:solidFill>
+                  <a:srgbClr val="FFFFFF"/>
+                </a:solidFill>
+                <a:latin typeface="Calibri" pitchFamily="34" charset="0"/>
+                <a:ea typeface="Calibri" pitchFamily="34" charset="-122"/>
+                <a:cs typeface="Calibri" pitchFamily="34" charset="-120"/>
+              </a:rPr>
+              <a:t>v</a:t>
+            </a:r>
+            <a:endParaRPr lang="en-US" sz="1300" dirty="0"/>
+          </a:p>
+        </p:txBody>
+      </p:sp>
+      <p:sp>
+        <p:nvSpPr>
+          <p:cNvPr id="22" name="Text 20"/>
+          <p:cNvSpPr/>
+          <p:nvPr/>
+        </p:nvSpPr>
+        <p:spPr>
+          <a:xfrm>
+            <a:off x="1252728" y="5321808"/>
+            <a:ext cx="10177272" cy="411480"/>
+          </a:xfrm>
+          <a:prstGeom prst="rect">
+            <a:avLst/>
+          </a:prstGeom>
+          <a:noFill/>
+          <a:ln/>
+        </p:spPr>
+        <p:txBody>
+          <a:bodyPr wrap="square" lIns="0" tIns="0" rIns="0" bIns="0" rtlCol="0" anchor="ctr"/>
+          <a:lstStyle/>
+          <a:p>
+            <a:pPr indent="0" marL="0">
+              <a:buNone/>
+            </a:pPr>
+            <a:r>
+              <a:rPr lang="en-US" sz="1400" dirty="0">
                 <a:solidFill>
                   <a:srgbClr val="15211D"/>
                 </a:solidFill>
@@ -6905,38 +7818,38 @@
                 <a:ea typeface="Calibri" pitchFamily="34" charset="-122"/>
                 <a:cs typeface="Calibri" pitchFamily="34" charset="-120"/>
               </a:rPr>
-              <a:t>인수인계 절차</a:t>
-            </a:r>
-            <a:endParaRPr lang="en-US" sz="1900" dirty="0"/>
-          </a:p>
-        </p:txBody>
-      </p:sp>
-      <p:sp>
-        <p:nvSpPr>
-          <p:cNvPr id="18" name="Text 16"/>
-          <p:cNvSpPr/>
-          <p:nvPr/>
-        </p:nvSpPr>
-        <p:spPr>
-          <a:xfrm>
-            <a:off x="4297680" y="4544568"/>
-            <a:ext cx="6885432" cy="804672"/>
-          </a:xfrm>
-          <a:prstGeom prst="rect">
-            <a:avLst/>
-          </a:prstGeom>
-          <a:noFill/>
-          <a:ln/>
-        </p:spPr>
-        <p:txBody>
-          <a:bodyPr wrap="square" lIns="0" tIns="0" rIns="0" bIns="0" rtlCol="0" anchor="ctr"/>
-          <a:lstStyle/>
-          <a:p>
-            <a:pPr indent="0" marL="0">
-              <a:buNone/>
-            </a:pPr>
-            <a:r>
-              <a:rPr lang="en-US" sz="1350" dirty="0">
+              <a:t>발송 이력이 자동 기록되어, 같은 달 중복 발송이 시스템 차원에서 차단되는 것을 확인했습니다.</a:t>
+            </a:r>
+            <a:endParaRPr lang="en-US" sz="1400" dirty="0"/>
+          </a:p>
+        </p:txBody>
+      </p:sp>
+      <p:sp>
+        <p:nvSpPr>
+          <p:cNvPr id="23" name="Text 21"/>
+          <p:cNvSpPr/>
+          <p:nvPr/>
+        </p:nvSpPr>
+        <p:spPr>
+          <a:xfrm>
+            <a:off x="685800" y="6400800"/>
+            <a:ext cx="10817352" cy="274320"/>
+          </a:xfrm>
+          <a:prstGeom prst="rect">
+            <a:avLst/>
+          </a:prstGeom>
+          <a:noFill/>
+          <a:ln/>
+        </p:spPr>
+        <p:txBody>
+          <a:bodyPr wrap="square" lIns="0" tIns="0" rIns="0" bIns="0" rtlCol="0" anchor="ctr"/>
+          <a:lstStyle/>
+          <a:p>
+            <a:pPr algn="l" indent="0" marL="0">
+              <a:buNone/>
+            </a:pPr>
+            <a:r>
+              <a:rPr lang="en-US" sz="1000" dirty="0">
                 <a:solidFill>
                   <a:srgbClr val="5F7069"/>
                 </a:solidFill>
@@ -6944,92 +7857,9 @@
                 <a:ea typeface="Calibri" pitchFamily="34" charset="-122"/>
                 <a:cs typeface="Calibri" pitchFamily="34" charset="-120"/>
               </a:rPr>
-              <a:t>이 도구는 실행하는 사람의 계정으로 발송됩니다.</a:t>
-            </a:r>
-            <a:endParaRPr lang="en-US" sz="1350" dirty="0"/>
-          </a:p>
-          <a:p>
-            <a:pPr indent="0" marL="0">
-              <a:buNone/>
-            </a:pPr>
-            <a:r>
-              <a:rPr lang="en-US" sz="1350" dirty="0">
-                <a:solidFill>
-                  <a:srgbClr val="5F7069"/>
-                </a:solidFill>
-                <a:latin typeface="Calibri" pitchFamily="34" charset="0"/>
-                <a:ea typeface="Calibri" pitchFamily="34" charset="-122"/>
-                <a:cs typeface="Calibri" pitchFamily="34" charset="-120"/>
-              </a:rPr>
-              <a:t>담당자 변경 시 소유권 이전과 재승인 절차를 문서에 명시했습니다.</a:t>
-            </a:r>
-            <a:endParaRPr lang="en-US" sz="1350" dirty="0"/>
-          </a:p>
-        </p:txBody>
-      </p:sp>
-      <p:sp>
-        <p:nvSpPr>
-          <p:cNvPr id="19" name="Shape 17"/>
-          <p:cNvSpPr/>
-          <p:nvPr/>
-        </p:nvSpPr>
-        <p:spPr>
-          <a:xfrm>
-            <a:off x="685800" y="5715000"/>
-            <a:ext cx="10817352" cy="658368"/>
-          </a:xfrm>
-          <a:prstGeom prst="roundRect">
-            <a:avLst>
-              <a:gd name="adj" fmla="val 11111"/>
-            </a:avLst>
-          </a:prstGeom>
-          <a:solidFill>
-            <a:srgbClr val="0E2A22"/>
-          </a:solidFill>
-          <a:ln w="12700">
-            <a:solidFill>
-              <a:srgbClr val="0E2A22"/>
-            </a:solidFill>
-            <a:prstDash val="solid"/>
-          </a:ln>
-        </p:spPr>
-      </p:sp>
-      <p:sp>
-        <p:nvSpPr>
-          <p:cNvPr id="20" name="Text 18"/>
-          <p:cNvSpPr/>
-          <p:nvPr/>
-        </p:nvSpPr>
-        <p:spPr>
-          <a:xfrm>
-            <a:off x="1097280" y="5715000"/>
-            <a:ext cx="9994392" cy="658368"/>
-          </a:xfrm>
-          <a:prstGeom prst="rect">
-            <a:avLst/>
-          </a:prstGeom>
-          <a:noFill/>
-          <a:ln/>
-        </p:spPr>
-        <p:txBody>
-          <a:bodyPr wrap="square" lIns="0" tIns="0" rIns="0" bIns="0" rtlCol="0" anchor="ctr"/>
-          <a:lstStyle/>
-          <a:p>
-            <a:pPr indent="0" marL="0">
-              <a:buNone/>
-            </a:pPr>
-            <a:r>
-              <a:rPr lang="en-US" sz="1500" dirty="0">
-                <a:solidFill>
-                  <a:srgbClr val="FFFFFF"/>
-                </a:solidFill>
-                <a:latin typeface="Calibri" pitchFamily="34" charset="0"/>
-                <a:ea typeface="Calibri" pitchFamily="34" charset="-122"/>
-                <a:cs typeface="Calibri" pitchFamily="34" charset="-120"/>
-              </a:rPr>
-              <a:t>매월 ERP 최신본만 붙여넣으면, 휴직 · 퇴직 · 신규 입사자가 자동으로 반영됩니다</a:t>
-            </a:r>
-            <a:endParaRPr lang="en-US" sz="1500" dirty="0"/>
+              <a:t>9월 이후 안내도 동일한 절차로 진행 예정</a:t>
+            </a:r>
+            <a:endParaRPr lang="en-US" sz="1000" dirty="0"/>
           </a:p>
         </p:txBody>
       </p:sp>
@@ -7091,7 +7921,7 @@
                 <a:ea typeface="Calibri" pitchFamily="34" charset="-122"/>
                 <a:cs typeface="Calibri" pitchFamily="34" charset="-120"/>
               </a:rPr>
-              <a:t>기대 효과</a:t>
+              <a:t>지속가능한 운영 구조</a:t>
             </a:r>
             <a:endParaRPr lang="en-US" sz="3800" dirty="0"/>
           </a:p>
@@ -7099,18 +7929,57 @@
       </p:sp>
       <p:sp>
         <p:nvSpPr>
-          <p:cNvPr id="3" name="Shape 1"/>
-          <p:cNvSpPr/>
-          <p:nvPr/>
-        </p:nvSpPr>
-        <p:spPr>
-          <a:xfrm>
-            <a:off x="685800" y="1737360"/>
-            <a:ext cx="3331464" cy="2377440"/>
+          <p:cNvPr id="3" name="Text 1"/>
+          <p:cNvSpPr/>
+          <p:nvPr/>
+        </p:nvSpPr>
+        <p:spPr>
+          <a:xfrm>
+            <a:off x="685800" y="1133856"/>
+            <a:ext cx="10817352" cy="365760"/>
+          </a:xfrm>
+          <a:prstGeom prst="rect">
+            <a:avLst/>
+          </a:prstGeom>
+          <a:noFill/>
+          <a:ln/>
+        </p:spPr>
+        <p:txBody>
+          <a:bodyPr wrap="square" lIns="0" tIns="0" rIns="0" bIns="0" rtlCol="0" anchor="ctr"/>
+          <a:lstStyle/>
+          <a:p>
+            <a:pPr indent="0" marL="0">
+              <a:buNone/>
+            </a:pPr>
+            <a:r>
+              <a:rPr lang="en-US" sz="1400" dirty="0">
+                <a:solidFill>
+                  <a:srgbClr val="5F7069"/>
+                </a:solidFill>
+                <a:latin typeface="Calibri" pitchFamily="34" charset="0"/>
+                <a:ea typeface="Calibri" pitchFamily="34" charset="-122"/>
+                <a:cs typeface="Calibri" pitchFamily="34" charset="-120"/>
+              </a:rPr>
+              <a:t>후임자가 코드를 몰라도 계속 쓸 수 있도록 설계했습니다</a:t>
+            </a:r>
+            <a:endParaRPr lang="en-US" sz="1400" dirty="0"/>
+          </a:p>
+        </p:txBody>
+      </p:sp>
+      <p:sp>
+        <p:nvSpPr>
+          <p:cNvPr id="4" name="Shape 2"/>
+          <p:cNvSpPr/>
+          <p:nvPr/>
+        </p:nvSpPr>
+        <p:spPr>
+          <a:xfrm>
+            <a:off x="685800" y="1783080"/>
+            <a:ext cx="10817352" cy="1115568"/>
           </a:xfrm>
           <a:prstGeom prst="roundRect">
             <a:avLst>
-              <a:gd name="adj" fmla="val 3077"/>
+              <a:gd name="adj" fmla="val 6557"/>
             </a:avLst>
           </a:prstGeom>
           <a:solidFill>
@@ -7126,30 +7995,128 @@
       </p:sp>
       <p:sp>
         <p:nvSpPr>
-          <p:cNvPr id="4" name="Text 2"/>
-          <p:cNvSpPr/>
-          <p:nvPr/>
-        </p:nvSpPr>
-        <p:spPr>
-          <a:xfrm>
-            <a:off x="978408" y="1965960"/>
-            <a:ext cx="2746248" cy="292608"/>
-          </a:xfrm>
-          <a:prstGeom prst="rect">
-            <a:avLst/>
-          </a:prstGeom>
-          <a:noFill/>
-          <a:ln/>
-        </p:spPr>
-        <p:txBody>
-          <a:bodyPr wrap="square" lIns="0" tIns="0" rIns="0" bIns="0" rtlCol="0" anchor="ctr"/>
-          <a:lstStyle/>
-          <a:p>
-            <a:pPr indent="0" marL="0">
-              <a:buNone/>
-            </a:pPr>
-            <a:r>
-              <a:rPr lang="en-US" sz="1200" b="1" spc="100" kern="0" dirty="0">
+          <p:cNvPr id="5" name="Shape 3"/>
+          <p:cNvSpPr/>
+          <p:nvPr/>
+        </p:nvSpPr>
+        <p:spPr>
+          <a:xfrm>
+            <a:off x="1005840" y="2112264"/>
+            <a:ext cx="457200" cy="457200"/>
+          </a:xfrm>
+          <a:prstGeom prst="ellipse">
+            <a:avLst/>
+          </a:prstGeom>
+          <a:solidFill>
+            <a:srgbClr val="00C878"/>
+          </a:solidFill>
+          <a:ln/>
+        </p:spPr>
+      </p:sp>
+      <p:sp>
+        <p:nvSpPr>
+          <p:cNvPr id="6" name="Text 4"/>
+          <p:cNvSpPr/>
+          <p:nvPr/>
+        </p:nvSpPr>
+        <p:spPr>
+          <a:xfrm>
+            <a:off x="1005840" y="2112264"/>
+            <a:ext cx="457200" cy="457200"/>
+          </a:xfrm>
+          <a:prstGeom prst="rect">
+            <a:avLst/>
+          </a:prstGeom>
+          <a:noFill/>
+          <a:ln/>
+        </p:spPr>
+        <p:txBody>
+          <a:bodyPr wrap="square" lIns="0" tIns="0" rIns="0" bIns="0" rtlCol="0" anchor="ctr"/>
+          <a:lstStyle/>
+          <a:p>
+            <a:pPr algn="ctr" indent="0" marL="0">
+              <a:buNone/>
+            </a:pPr>
+            <a:r>
+              <a:rPr lang="en-US" sz="1400" b="1" dirty="0">
+                <a:solidFill>
+                  <a:srgbClr val="FFFFFF"/>
+                </a:solidFill>
+                <a:latin typeface="Calibri" pitchFamily="34" charset="0"/>
+                <a:ea typeface="Calibri" pitchFamily="34" charset="-122"/>
+                <a:cs typeface="Calibri" pitchFamily="34" charset="-120"/>
+              </a:rPr>
+              <a:t>1</a:t>
+            </a:r>
+            <a:endParaRPr lang="en-US" sz="1400" dirty="0"/>
+          </a:p>
+        </p:txBody>
+      </p:sp>
+      <p:sp>
+        <p:nvSpPr>
+          <p:cNvPr id="7" name="Text 5"/>
+          <p:cNvSpPr/>
+          <p:nvPr/>
+        </p:nvSpPr>
+        <p:spPr>
+          <a:xfrm>
+            <a:off x="1645920" y="1984248"/>
+            <a:ext cx="2468880" cy="384048"/>
+          </a:xfrm>
+          <a:prstGeom prst="rect">
+            <a:avLst/>
+          </a:prstGeom>
+          <a:noFill/>
+          <a:ln/>
+        </p:spPr>
+        <p:txBody>
+          <a:bodyPr wrap="square" lIns="0" tIns="0" rIns="0" bIns="0" rtlCol="0" anchor="ctr"/>
+          <a:lstStyle/>
+          <a:p>
+            <a:pPr indent="0" marL="0">
+              <a:buNone/>
+            </a:pPr>
+            <a:r>
+              <a:rPr lang="en-US" sz="1900" b="1" dirty="0">
+                <a:solidFill>
+                  <a:srgbClr val="15211D"/>
+                </a:solidFill>
+                <a:latin typeface="Calibri" pitchFamily="34" charset="0"/>
+                <a:ea typeface="Calibri" pitchFamily="34" charset="-122"/>
+                <a:cs typeface="Calibri" pitchFamily="34" charset="-120"/>
+              </a:rPr>
+              <a:t>설정 시트</a:t>
+            </a:r>
+            <a:endParaRPr lang="en-US" sz="1900" dirty="0"/>
+          </a:p>
+        </p:txBody>
+      </p:sp>
+      <p:sp>
+        <p:nvSpPr>
+          <p:cNvPr id="8" name="Text 6"/>
+          <p:cNvSpPr/>
+          <p:nvPr/>
+        </p:nvSpPr>
+        <p:spPr>
+          <a:xfrm>
+            <a:off x="4297680" y="1947672"/>
+            <a:ext cx="6885432" cy="804672"/>
+          </a:xfrm>
+          <a:prstGeom prst="rect">
+            <a:avLst/>
+          </a:prstGeom>
+          <a:noFill/>
+          <a:ln/>
+        </p:spPr>
+        <p:txBody>
+          <a:bodyPr wrap="square" lIns="0" tIns="0" rIns="0" bIns="0" rtlCol="0" anchor="ctr"/>
+          <a:lstStyle/>
+          <a:p>
+            <a:pPr indent="0" marL="0">
+              <a:buNone/>
+            </a:pPr>
+            <a:r>
+              <a:rPr lang="en-US" sz="1350" dirty="0">
                 <a:solidFill>
                   <a:srgbClr val="5F7069"/>
                 </a:solidFill>
@@ -7157,143 +8124,43 @@
                 <a:ea typeface="Calibri" pitchFamily="34" charset="-122"/>
                 <a:cs typeface="Calibri" pitchFamily="34" charset="-120"/>
               </a:rPr>
-              <a:t>작업 시간</a:t>
-            </a:r>
-            <a:endParaRPr lang="en-US" sz="1200" dirty="0"/>
-          </a:p>
-        </p:txBody>
-      </p:sp>
-      <p:sp>
-        <p:nvSpPr>
-          <p:cNvPr id="5" name="Text 3"/>
-          <p:cNvSpPr/>
-          <p:nvPr/>
-        </p:nvSpPr>
-        <p:spPr>
-          <a:xfrm>
-            <a:off x="978408" y="2359152"/>
-            <a:ext cx="2746248" cy="457200"/>
-          </a:xfrm>
-          <a:prstGeom prst="rect">
-            <a:avLst/>
-          </a:prstGeom>
-          <a:noFill/>
-          <a:ln/>
-        </p:spPr>
-        <p:txBody>
-          <a:bodyPr wrap="square" lIns="0" tIns="0" rIns="0" bIns="0" rtlCol="0" anchor="ctr"/>
-          <a:lstStyle/>
-          <a:p>
-            <a:pPr indent="0" marL="0">
-              <a:buNone/>
-            </a:pPr>
-            <a:r>
-              <a:rPr lang="en-US" sz="1500" strike="sngStrike" dirty="0">
-                <a:solidFill>
-                  <a:srgbClr val="96A6A0"/>
-                </a:solidFill>
-                <a:latin typeface="Calibri" pitchFamily="34" charset="0"/>
-                <a:ea typeface="Calibri" pitchFamily="34" charset="-122"/>
-                <a:cs typeface="Calibri" pitchFamily="34" charset="-120"/>
-              </a:rPr>
-              <a:t>월 1.5~2시간</a:t>
-            </a:r>
-            <a:endParaRPr lang="en-US" sz="1500" dirty="0"/>
-          </a:p>
-        </p:txBody>
-      </p:sp>
-      <p:sp>
-        <p:nvSpPr>
-          <p:cNvPr id="6" name="Text 4"/>
-          <p:cNvSpPr/>
-          <p:nvPr/>
-        </p:nvSpPr>
-        <p:spPr>
-          <a:xfrm>
-            <a:off x="978408" y="2816352"/>
-            <a:ext cx="2746248" cy="292608"/>
-          </a:xfrm>
-          <a:prstGeom prst="rect">
-            <a:avLst/>
-          </a:prstGeom>
-          <a:noFill/>
-          <a:ln/>
-        </p:spPr>
-        <p:txBody>
-          <a:bodyPr wrap="square" lIns="0" tIns="0" rIns="0" bIns="0" rtlCol="0" anchor="ctr"/>
-          <a:lstStyle/>
-          <a:p>
-            <a:pPr indent="0" marL="0">
-              <a:buNone/>
-            </a:pPr>
-            <a:r>
-              <a:rPr lang="en-US" sz="1400" dirty="0">
-                <a:solidFill>
-                  <a:srgbClr val="00C878"/>
-                </a:solidFill>
-                <a:latin typeface="Calibri" pitchFamily="34" charset="0"/>
-                <a:ea typeface="Calibri" pitchFamily="34" charset="-122"/>
-                <a:cs typeface="Calibri" pitchFamily="34" charset="-120"/>
-              </a:rPr>
-              <a:t>↓</a:t>
-            </a:r>
-            <a:endParaRPr lang="en-US" sz="1400" dirty="0"/>
-          </a:p>
-        </p:txBody>
-      </p:sp>
-      <p:sp>
-        <p:nvSpPr>
-          <p:cNvPr id="7" name="Text 5"/>
-          <p:cNvSpPr/>
-          <p:nvPr/>
-        </p:nvSpPr>
-        <p:spPr>
-          <a:xfrm>
-            <a:off x="978408" y="3127248"/>
-            <a:ext cx="2746248" cy="777240"/>
-          </a:xfrm>
-          <a:prstGeom prst="rect">
-            <a:avLst/>
-          </a:prstGeom>
-          <a:noFill/>
-          <a:ln/>
-        </p:spPr>
-        <p:txBody>
-          <a:bodyPr wrap="square" lIns="0" tIns="0" rIns="0" bIns="0" rtlCol="0" anchor="ctr"/>
-          <a:lstStyle/>
-          <a:p>
-            <a:pPr indent="0" marL="0">
-              <a:buNone/>
-            </a:pPr>
-            <a:r>
-              <a:rPr lang="en-US" sz="2100" b="1" dirty="0">
-                <a:solidFill>
-                  <a:srgbClr val="15211D"/>
-                </a:solidFill>
-                <a:latin typeface="Calibri" pitchFamily="34" charset="0"/>
-                <a:ea typeface="Calibri" pitchFamily="34" charset="-122"/>
-                <a:cs typeface="Calibri" pitchFamily="34" charset="-120"/>
-              </a:rPr>
-              <a:t>5분 이내</a:t>
-            </a:r>
-            <a:endParaRPr lang="en-US" sz="2100" dirty="0"/>
-          </a:p>
-        </p:txBody>
-      </p:sp>
-      <p:sp>
-        <p:nvSpPr>
-          <p:cNvPr id="8" name="Shape 6"/>
-          <p:cNvSpPr/>
-          <p:nvPr/>
-        </p:nvSpPr>
-        <p:spPr>
-          <a:xfrm>
-            <a:off x="4428744" y="1737360"/>
-            <a:ext cx="3331464" cy="2377440"/>
+              <a:t>메일 제목 · 본문 · 제외 규칙 · 발신자명을 스프레드시트에서 직접 수정.</a:t>
+            </a:r>
+            <a:endParaRPr lang="en-US" sz="1350" dirty="0"/>
+          </a:p>
+          <a:p>
+            <a:pPr indent="0" marL="0">
+              <a:buNone/>
+            </a:pPr>
+            <a:r>
+              <a:rPr lang="en-US" sz="1350" dirty="0">
+                <a:solidFill>
+                  <a:srgbClr val="5F7069"/>
+                </a:solidFill>
+                <a:latin typeface="Calibri" pitchFamily="34" charset="0"/>
+                <a:ea typeface="Calibri" pitchFamily="34" charset="-122"/>
+                <a:cs typeface="Calibri" pitchFamily="34" charset="-120"/>
+              </a:rPr>
+              <a:t>코드를 열 필요가 없습니다.</a:t>
+            </a:r>
+            <a:endParaRPr lang="en-US" sz="1350" dirty="0"/>
+          </a:p>
+        </p:txBody>
+      </p:sp>
+      <p:sp>
+        <p:nvSpPr>
+          <p:cNvPr id="9" name="Shape 7"/>
+          <p:cNvSpPr/>
+          <p:nvPr/>
+        </p:nvSpPr>
+        <p:spPr>
+          <a:xfrm>
+            <a:off x="685800" y="3081528"/>
+            <a:ext cx="10817352" cy="1115568"/>
           </a:xfrm>
           <a:prstGeom prst="roundRect">
             <a:avLst>
-              <a:gd name="adj" fmla="val 3077"/>
+              <a:gd name="adj" fmla="val 6557"/>
             </a:avLst>
           </a:prstGeom>
           <a:solidFill>
@@ -7309,30 +8176,128 @@
       </p:sp>
       <p:sp>
         <p:nvSpPr>
-          <p:cNvPr id="9" name="Text 7"/>
-          <p:cNvSpPr/>
-          <p:nvPr/>
-        </p:nvSpPr>
-        <p:spPr>
-          <a:xfrm>
-            <a:off x="4721352" y="1965960"/>
-            <a:ext cx="2746248" cy="292608"/>
-          </a:xfrm>
-          <a:prstGeom prst="rect">
-            <a:avLst/>
-          </a:prstGeom>
-          <a:noFill/>
-          <a:ln/>
-        </p:spPr>
-        <p:txBody>
-          <a:bodyPr wrap="square" lIns="0" tIns="0" rIns="0" bIns="0" rtlCol="0" anchor="ctr"/>
-          <a:lstStyle/>
-          <a:p>
-            <a:pPr indent="0" marL="0">
-              <a:buNone/>
-            </a:pPr>
-            <a:r>
-              <a:rPr lang="en-US" sz="1200" b="1" spc="100" kern="0" dirty="0">
+          <p:cNvPr id="10" name="Shape 8"/>
+          <p:cNvSpPr/>
+          <p:nvPr/>
+        </p:nvSpPr>
+        <p:spPr>
+          <a:xfrm>
+            <a:off x="1005840" y="3410712"/>
+            <a:ext cx="457200" cy="457200"/>
+          </a:xfrm>
+          <a:prstGeom prst="ellipse">
+            <a:avLst/>
+          </a:prstGeom>
+          <a:solidFill>
+            <a:srgbClr val="00C878"/>
+          </a:solidFill>
+          <a:ln/>
+        </p:spPr>
+      </p:sp>
+      <p:sp>
+        <p:nvSpPr>
+          <p:cNvPr id="11" name="Text 9"/>
+          <p:cNvSpPr/>
+          <p:nvPr/>
+        </p:nvSpPr>
+        <p:spPr>
+          <a:xfrm>
+            <a:off x="1005840" y="3410712"/>
+            <a:ext cx="457200" cy="457200"/>
+          </a:xfrm>
+          <a:prstGeom prst="rect">
+            <a:avLst/>
+          </a:prstGeom>
+          <a:noFill/>
+          <a:ln/>
+        </p:spPr>
+        <p:txBody>
+          <a:bodyPr wrap="square" lIns="0" tIns="0" rIns="0" bIns="0" rtlCol="0" anchor="ctr"/>
+          <a:lstStyle/>
+          <a:p>
+            <a:pPr algn="ctr" indent="0" marL="0">
+              <a:buNone/>
+            </a:pPr>
+            <a:r>
+              <a:rPr lang="en-US" sz="1400" b="1" dirty="0">
+                <a:solidFill>
+                  <a:srgbClr val="FFFFFF"/>
+                </a:solidFill>
+                <a:latin typeface="Calibri" pitchFamily="34" charset="0"/>
+                <a:ea typeface="Calibri" pitchFamily="34" charset="-122"/>
+                <a:cs typeface="Calibri" pitchFamily="34" charset="-120"/>
+              </a:rPr>
+              <a:t>2</a:t>
+            </a:r>
+            <a:endParaRPr lang="en-US" sz="1400" dirty="0"/>
+          </a:p>
+        </p:txBody>
+      </p:sp>
+      <p:sp>
+        <p:nvSpPr>
+          <p:cNvPr id="12" name="Text 10"/>
+          <p:cNvSpPr/>
+          <p:nvPr/>
+        </p:nvSpPr>
+        <p:spPr>
+          <a:xfrm>
+            <a:off x="1645920" y="3282696"/>
+            <a:ext cx="2468880" cy="384048"/>
+          </a:xfrm>
+          <a:prstGeom prst="rect">
+            <a:avLst/>
+          </a:prstGeom>
+          <a:noFill/>
+          <a:ln/>
+        </p:spPr>
+        <p:txBody>
+          <a:bodyPr wrap="square" lIns="0" tIns="0" rIns="0" bIns="0" rtlCol="0" anchor="ctr"/>
+          <a:lstStyle/>
+          <a:p>
+            <a:pPr indent="0" marL="0">
+              <a:buNone/>
+            </a:pPr>
+            <a:r>
+              <a:rPr lang="en-US" sz="1900" b="1" dirty="0">
+                <a:solidFill>
+                  <a:srgbClr val="15211D"/>
+                </a:solidFill>
+                <a:latin typeface="Calibri" pitchFamily="34" charset="0"/>
+                <a:ea typeface="Calibri" pitchFamily="34" charset="-122"/>
+                <a:cs typeface="Calibri" pitchFamily="34" charset="-120"/>
+              </a:rPr>
+              <a:t>사용법 시트</a:t>
+            </a:r>
+            <a:endParaRPr lang="en-US" sz="1900" dirty="0"/>
+          </a:p>
+        </p:txBody>
+      </p:sp>
+      <p:sp>
+        <p:nvSpPr>
+          <p:cNvPr id="13" name="Text 11"/>
+          <p:cNvSpPr/>
+          <p:nvPr/>
+        </p:nvSpPr>
+        <p:spPr>
+          <a:xfrm>
+            <a:off x="4297680" y="3246120"/>
+            <a:ext cx="6885432" cy="804672"/>
+          </a:xfrm>
+          <a:prstGeom prst="rect">
+            <a:avLst/>
+          </a:prstGeom>
+          <a:noFill/>
+          <a:ln/>
+        </p:spPr>
+        <p:txBody>
+          <a:bodyPr wrap="square" lIns="0" tIns="0" rIns="0" bIns="0" rtlCol="0" anchor="ctr"/>
+          <a:lstStyle/>
+          <a:p>
+            <a:pPr indent="0" marL="0">
+              <a:buNone/>
+            </a:pPr>
+            <a:r>
+              <a:rPr lang="en-US" sz="1350" dirty="0">
                 <a:solidFill>
                   <a:srgbClr val="5F7069"/>
                 </a:solidFill>
@@ -7340,143 +8305,43 @@
                 <a:ea typeface="Calibri" pitchFamily="34" charset="-122"/>
                 <a:cs typeface="Calibri" pitchFamily="34" charset="-120"/>
               </a:rPr>
-              <a:t>대상자 선별</a:t>
-            </a:r>
-            <a:endParaRPr lang="en-US" sz="1200" dirty="0"/>
-          </a:p>
-        </p:txBody>
-      </p:sp>
-      <p:sp>
-        <p:nvSpPr>
-          <p:cNvPr id="10" name="Text 8"/>
-          <p:cNvSpPr/>
-          <p:nvPr/>
-        </p:nvSpPr>
-        <p:spPr>
-          <a:xfrm>
-            <a:off x="4721352" y="2359152"/>
-            <a:ext cx="2746248" cy="457200"/>
-          </a:xfrm>
-          <a:prstGeom prst="rect">
-            <a:avLst/>
-          </a:prstGeom>
-          <a:noFill/>
-          <a:ln/>
-        </p:spPr>
-        <p:txBody>
-          <a:bodyPr wrap="square" lIns="0" tIns="0" rIns="0" bIns="0" rtlCol="0" anchor="ctr"/>
-          <a:lstStyle/>
-          <a:p>
-            <a:pPr indent="0" marL="0">
-              <a:buNone/>
-            </a:pPr>
-            <a:r>
-              <a:rPr lang="en-US" sz="1500" strike="sngStrike" dirty="0">
-                <a:solidFill>
-                  <a:srgbClr val="96A6A0"/>
-                </a:solidFill>
-                <a:latin typeface="Calibri" pitchFamily="34" charset="0"/>
-                <a:ea typeface="Calibri" pitchFamily="34" charset="-122"/>
-                <a:cs typeface="Calibri" pitchFamily="34" charset="-120"/>
-              </a:rPr>
-              <a:t>수작업 대조</a:t>
-            </a:r>
-            <a:endParaRPr lang="en-US" sz="1500" dirty="0"/>
-          </a:p>
-        </p:txBody>
-      </p:sp>
-      <p:sp>
-        <p:nvSpPr>
-          <p:cNvPr id="11" name="Text 9"/>
-          <p:cNvSpPr/>
-          <p:nvPr/>
-        </p:nvSpPr>
-        <p:spPr>
-          <a:xfrm>
-            <a:off x="4721352" y="2816352"/>
-            <a:ext cx="2746248" cy="292608"/>
-          </a:xfrm>
-          <a:prstGeom prst="rect">
-            <a:avLst/>
-          </a:prstGeom>
-          <a:noFill/>
-          <a:ln/>
-        </p:spPr>
-        <p:txBody>
-          <a:bodyPr wrap="square" lIns="0" tIns="0" rIns="0" bIns="0" rtlCol="0" anchor="ctr"/>
-          <a:lstStyle/>
-          <a:p>
-            <a:pPr indent="0" marL="0">
-              <a:buNone/>
-            </a:pPr>
-            <a:r>
-              <a:rPr lang="en-US" sz="1400" dirty="0">
-                <a:solidFill>
-                  <a:srgbClr val="00C878"/>
-                </a:solidFill>
-                <a:latin typeface="Calibri" pitchFamily="34" charset="0"/>
-                <a:ea typeface="Calibri" pitchFamily="34" charset="-122"/>
-                <a:cs typeface="Calibri" pitchFamily="34" charset="-120"/>
-              </a:rPr>
-              <a:t>↓</a:t>
-            </a:r>
-            <a:endParaRPr lang="en-US" sz="1400" dirty="0"/>
-          </a:p>
-        </p:txBody>
-      </p:sp>
-      <p:sp>
-        <p:nvSpPr>
-          <p:cNvPr id="12" name="Text 10"/>
-          <p:cNvSpPr/>
-          <p:nvPr/>
-        </p:nvSpPr>
-        <p:spPr>
-          <a:xfrm>
-            <a:off x="4721352" y="3127248"/>
-            <a:ext cx="2746248" cy="777240"/>
-          </a:xfrm>
-          <a:prstGeom prst="rect">
-            <a:avLst/>
-          </a:prstGeom>
-          <a:noFill/>
-          <a:ln/>
-        </p:spPr>
-        <p:txBody>
-          <a:bodyPr wrap="square" lIns="0" tIns="0" rIns="0" bIns="0" rtlCol="0" anchor="ctr"/>
-          <a:lstStyle/>
-          <a:p>
-            <a:pPr indent="0" marL="0">
-              <a:buNone/>
-            </a:pPr>
-            <a:r>
-              <a:rPr lang="en-US" sz="2100" b="1" dirty="0">
-                <a:solidFill>
-                  <a:srgbClr val="15211D"/>
-                </a:solidFill>
-                <a:latin typeface="Calibri" pitchFamily="34" charset="0"/>
-                <a:ea typeface="Calibri" pitchFamily="34" charset="-122"/>
-                <a:cs typeface="Calibri" pitchFamily="34" charset="-120"/>
-              </a:rPr>
-              <a:t>규칙 기반 자동 판별</a:t>
-            </a:r>
-            <a:endParaRPr lang="en-US" sz="2100" dirty="0"/>
-          </a:p>
-        </p:txBody>
-      </p:sp>
-      <p:sp>
-        <p:nvSpPr>
-          <p:cNvPr id="13" name="Shape 11"/>
-          <p:cNvSpPr/>
-          <p:nvPr/>
-        </p:nvSpPr>
-        <p:spPr>
-          <a:xfrm>
-            <a:off x="8171688" y="1737360"/>
-            <a:ext cx="3331464" cy="2377440"/>
+              <a:t>매월 작업 순서와 문제 해결 방법을 스프레드시트 안에 문서로 내장.</a:t>
+            </a:r>
+            <a:endParaRPr lang="en-US" sz="1350" dirty="0"/>
+          </a:p>
+          <a:p>
+            <a:pPr indent="0" marL="0">
+              <a:buNone/>
+            </a:pPr>
+            <a:r>
+              <a:rPr lang="en-US" sz="1350" dirty="0">
+                <a:solidFill>
+                  <a:srgbClr val="5F7069"/>
+                </a:solidFill>
+                <a:latin typeface="Calibri" pitchFamily="34" charset="0"/>
+                <a:ea typeface="Calibri" pitchFamily="34" charset="-122"/>
+                <a:cs typeface="Calibri" pitchFamily="34" charset="-120"/>
+              </a:rPr>
+              <a:t>별도 매뉴얼 관리가 불필요합니다.</a:t>
+            </a:r>
+            <a:endParaRPr lang="en-US" sz="1350" dirty="0"/>
+          </a:p>
+        </p:txBody>
+      </p:sp>
+      <p:sp>
+        <p:nvSpPr>
+          <p:cNvPr id="14" name="Shape 12"/>
+          <p:cNvSpPr/>
+          <p:nvPr/>
+        </p:nvSpPr>
+        <p:spPr>
+          <a:xfrm>
+            <a:off x="685800" y="4379976"/>
+            <a:ext cx="10817352" cy="1115568"/>
           </a:xfrm>
           <a:prstGeom prst="roundRect">
             <a:avLst>
-              <a:gd name="adj" fmla="val 3077"/>
+              <a:gd name="adj" fmla="val 6557"/>
             </a:avLst>
           </a:prstGeom>
           <a:solidFill>
@@ -7492,30 +8357,128 @@
       </p:sp>
       <p:sp>
         <p:nvSpPr>
-          <p:cNvPr id="14" name="Text 12"/>
-          <p:cNvSpPr/>
-          <p:nvPr/>
-        </p:nvSpPr>
-        <p:spPr>
-          <a:xfrm>
-            <a:off x="8464296" y="1965960"/>
-            <a:ext cx="2746248" cy="292608"/>
-          </a:xfrm>
-          <a:prstGeom prst="rect">
-            <a:avLst/>
-          </a:prstGeom>
-          <a:noFill/>
-          <a:ln/>
-        </p:spPr>
-        <p:txBody>
-          <a:bodyPr wrap="square" lIns="0" tIns="0" rIns="0" bIns="0" rtlCol="0" anchor="ctr"/>
-          <a:lstStyle/>
-          <a:p>
-            <a:pPr indent="0" marL="0">
-              <a:buNone/>
-            </a:pPr>
-            <a:r>
-              <a:rPr lang="en-US" sz="1200" b="1" spc="100" kern="0" dirty="0">
+          <p:cNvPr id="15" name="Shape 13"/>
+          <p:cNvSpPr/>
+          <p:nvPr/>
+        </p:nvSpPr>
+        <p:spPr>
+          <a:xfrm>
+            <a:off x="1005840" y="4709160"/>
+            <a:ext cx="457200" cy="457200"/>
+          </a:xfrm>
+          <a:prstGeom prst="ellipse">
+            <a:avLst/>
+          </a:prstGeom>
+          <a:solidFill>
+            <a:srgbClr val="00C878"/>
+          </a:solidFill>
+          <a:ln/>
+        </p:spPr>
+      </p:sp>
+      <p:sp>
+        <p:nvSpPr>
+          <p:cNvPr id="16" name="Text 14"/>
+          <p:cNvSpPr/>
+          <p:nvPr/>
+        </p:nvSpPr>
+        <p:spPr>
+          <a:xfrm>
+            <a:off x="1005840" y="4709160"/>
+            <a:ext cx="457200" cy="457200"/>
+          </a:xfrm>
+          <a:prstGeom prst="rect">
+            <a:avLst/>
+          </a:prstGeom>
+          <a:noFill/>
+          <a:ln/>
+        </p:spPr>
+        <p:txBody>
+          <a:bodyPr wrap="square" lIns="0" tIns="0" rIns="0" bIns="0" rtlCol="0" anchor="ctr"/>
+          <a:lstStyle/>
+          <a:p>
+            <a:pPr algn="ctr" indent="0" marL="0">
+              <a:buNone/>
+            </a:pPr>
+            <a:r>
+              <a:rPr lang="en-US" sz="1400" b="1" dirty="0">
+                <a:solidFill>
+                  <a:srgbClr val="FFFFFF"/>
+                </a:solidFill>
+                <a:latin typeface="Calibri" pitchFamily="34" charset="0"/>
+                <a:ea typeface="Calibri" pitchFamily="34" charset="-122"/>
+                <a:cs typeface="Calibri" pitchFamily="34" charset="-120"/>
+              </a:rPr>
+              <a:t>3</a:t>
+            </a:r>
+            <a:endParaRPr lang="en-US" sz="1400" dirty="0"/>
+          </a:p>
+        </p:txBody>
+      </p:sp>
+      <p:sp>
+        <p:nvSpPr>
+          <p:cNvPr id="17" name="Text 15"/>
+          <p:cNvSpPr/>
+          <p:nvPr/>
+        </p:nvSpPr>
+        <p:spPr>
+          <a:xfrm>
+            <a:off x="1645920" y="4581144"/>
+            <a:ext cx="2468880" cy="384048"/>
+          </a:xfrm>
+          <a:prstGeom prst="rect">
+            <a:avLst/>
+          </a:prstGeom>
+          <a:noFill/>
+          <a:ln/>
+        </p:spPr>
+        <p:txBody>
+          <a:bodyPr wrap="square" lIns="0" tIns="0" rIns="0" bIns="0" rtlCol="0" anchor="ctr"/>
+          <a:lstStyle/>
+          <a:p>
+            <a:pPr indent="0" marL="0">
+              <a:buNone/>
+            </a:pPr>
+            <a:r>
+              <a:rPr lang="en-US" sz="1900" b="1" dirty="0">
+                <a:solidFill>
+                  <a:srgbClr val="15211D"/>
+                </a:solidFill>
+                <a:latin typeface="Calibri" pitchFamily="34" charset="0"/>
+                <a:ea typeface="Calibri" pitchFamily="34" charset="-122"/>
+                <a:cs typeface="Calibri" pitchFamily="34" charset="-120"/>
+              </a:rPr>
+              <a:t>인수인계 절차</a:t>
+            </a:r>
+            <a:endParaRPr lang="en-US" sz="1900" dirty="0"/>
+          </a:p>
+        </p:txBody>
+      </p:sp>
+      <p:sp>
+        <p:nvSpPr>
+          <p:cNvPr id="18" name="Text 16"/>
+          <p:cNvSpPr/>
+          <p:nvPr/>
+        </p:nvSpPr>
+        <p:spPr>
+          <a:xfrm>
+            <a:off x="4297680" y="4544568"/>
+            <a:ext cx="6885432" cy="804672"/>
+          </a:xfrm>
+          <a:prstGeom prst="rect">
+            <a:avLst/>
+          </a:prstGeom>
+          <a:noFill/>
+          <a:ln/>
+        </p:spPr>
+        <p:txBody>
+          <a:bodyPr wrap="square" lIns="0" tIns="0" rIns="0" bIns="0" rtlCol="0" anchor="ctr"/>
+          <a:lstStyle/>
+          <a:p>
+            <a:pPr indent="0" marL="0">
+              <a:buNone/>
+            </a:pPr>
+            <a:r>
+              <a:rPr lang="en-US" sz="1350" dirty="0">
                 <a:solidFill>
                   <a:srgbClr val="5F7069"/>
                 </a:solidFill>
@@ -7523,151 +8486,51 @@
                 <a:ea typeface="Calibri" pitchFamily="34" charset="-122"/>
                 <a:cs typeface="Calibri" pitchFamily="34" charset="-120"/>
               </a:rPr>
-              <a:t>업무 인수인계</a:t>
-            </a:r>
-            <a:endParaRPr lang="en-US" sz="1200" dirty="0"/>
-          </a:p>
-        </p:txBody>
-      </p:sp>
-      <p:sp>
-        <p:nvSpPr>
-          <p:cNvPr id="15" name="Text 13"/>
-          <p:cNvSpPr/>
-          <p:nvPr/>
-        </p:nvSpPr>
-        <p:spPr>
-          <a:xfrm>
-            <a:off x="8464296" y="2359152"/>
-            <a:ext cx="2746248" cy="457200"/>
-          </a:xfrm>
-          <a:prstGeom prst="rect">
-            <a:avLst/>
-          </a:prstGeom>
-          <a:noFill/>
-          <a:ln/>
-        </p:spPr>
-        <p:txBody>
-          <a:bodyPr wrap="square" lIns="0" tIns="0" rIns="0" bIns="0" rtlCol="0" anchor="ctr"/>
-          <a:lstStyle/>
-          <a:p>
-            <a:pPr indent="0" marL="0">
-              <a:buNone/>
-            </a:pPr>
-            <a:r>
-              <a:rPr lang="en-US" sz="1500" strike="sngStrike" dirty="0">
-                <a:solidFill>
-                  <a:srgbClr val="96A6A0"/>
-                </a:solidFill>
-                <a:latin typeface="Calibri" pitchFamily="34" charset="0"/>
-                <a:ea typeface="Calibri" pitchFamily="34" charset="-122"/>
-                <a:cs typeface="Calibri" pitchFamily="34" charset="-120"/>
-              </a:rPr>
-              <a:t>담당자 기억에 의존</a:t>
-            </a:r>
-            <a:endParaRPr lang="en-US" sz="1500" dirty="0"/>
-          </a:p>
-        </p:txBody>
-      </p:sp>
-      <p:sp>
-        <p:nvSpPr>
-          <p:cNvPr id="16" name="Text 14"/>
-          <p:cNvSpPr/>
-          <p:nvPr/>
-        </p:nvSpPr>
-        <p:spPr>
-          <a:xfrm>
-            <a:off x="8464296" y="2816352"/>
-            <a:ext cx="2746248" cy="292608"/>
-          </a:xfrm>
-          <a:prstGeom prst="rect">
-            <a:avLst/>
-          </a:prstGeom>
-          <a:noFill/>
-          <a:ln/>
-        </p:spPr>
-        <p:txBody>
-          <a:bodyPr wrap="square" lIns="0" tIns="0" rIns="0" bIns="0" rtlCol="0" anchor="ctr"/>
-          <a:lstStyle/>
-          <a:p>
-            <a:pPr indent="0" marL="0">
-              <a:buNone/>
-            </a:pPr>
-            <a:r>
-              <a:rPr lang="en-US" sz="1400" dirty="0">
-                <a:solidFill>
-                  <a:srgbClr val="00C878"/>
-                </a:solidFill>
-                <a:latin typeface="Calibri" pitchFamily="34" charset="0"/>
-                <a:ea typeface="Calibri" pitchFamily="34" charset="-122"/>
-                <a:cs typeface="Calibri" pitchFamily="34" charset="-120"/>
-              </a:rPr>
-              <a:t>↓</a:t>
-            </a:r>
-            <a:endParaRPr lang="en-US" sz="1400" dirty="0"/>
-          </a:p>
-        </p:txBody>
-      </p:sp>
-      <p:sp>
-        <p:nvSpPr>
-          <p:cNvPr id="17" name="Text 15"/>
-          <p:cNvSpPr/>
-          <p:nvPr/>
-        </p:nvSpPr>
-        <p:spPr>
-          <a:xfrm>
-            <a:off x="8464296" y="3127248"/>
-            <a:ext cx="2746248" cy="777240"/>
-          </a:xfrm>
-          <a:prstGeom prst="rect">
-            <a:avLst/>
-          </a:prstGeom>
-          <a:noFill/>
-          <a:ln/>
-        </p:spPr>
-        <p:txBody>
-          <a:bodyPr wrap="square" lIns="0" tIns="0" rIns="0" bIns="0" rtlCol="0" anchor="ctr"/>
-          <a:lstStyle/>
-          <a:p>
-            <a:pPr indent="0" marL="0">
-              <a:buNone/>
-            </a:pPr>
-            <a:r>
-              <a:rPr lang="en-US" sz="2100" b="1" dirty="0">
-                <a:solidFill>
-                  <a:srgbClr val="15211D"/>
-                </a:solidFill>
-                <a:latin typeface="Calibri" pitchFamily="34" charset="0"/>
-                <a:ea typeface="Calibri" pitchFamily="34" charset="-122"/>
-                <a:cs typeface="Calibri" pitchFamily="34" charset="-120"/>
-              </a:rPr>
-              <a:t>문서 · 설정 내장</a:t>
-            </a:r>
-            <a:endParaRPr lang="en-US" sz="2100" dirty="0"/>
-          </a:p>
-        </p:txBody>
-      </p:sp>
-      <p:sp>
-        <p:nvSpPr>
-          <p:cNvPr id="18" name="Shape 16"/>
-          <p:cNvSpPr/>
-          <p:nvPr/>
-        </p:nvSpPr>
-        <p:spPr>
-          <a:xfrm>
-            <a:off x="685800" y="4434840"/>
-            <a:ext cx="10817352" cy="1371600"/>
+              <a:t>이 도구는 실행하는 사람의 계정으로 발송됩니다.</a:t>
+            </a:r>
+            <a:endParaRPr lang="en-US" sz="1350" dirty="0"/>
+          </a:p>
+          <a:p>
+            <a:pPr indent="0" marL="0">
+              <a:buNone/>
+            </a:pPr>
+            <a:r>
+              <a:rPr lang="en-US" sz="1350" dirty="0">
+                <a:solidFill>
+                  <a:srgbClr val="5F7069"/>
+                </a:solidFill>
+                <a:latin typeface="Calibri" pitchFamily="34" charset="0"/>
+                <a:ea typeface="Calibri" pitchFamily="34" charset="-122"/>
+                <a:cs typeface="Calibri" pitchFamily="34" charset="-120"/>
+              </a:rPr>
+              <a:t>담당자 변경 시 소유권 이전과 재승인 절차를 문서에 명시했습니다.</a:t>
+            </a:r>
+            <a:endParaRPr lang="en-US" sz="1350" dirty="0"/>
+          </a:p>
+        </p:txBody>
+      </p:sp>
+      <p:sp>
+        <p:nvSpPr>
+          <p:cNvPr id="19" name="Shape 17"/>
+          <p:cNvSpPr/>
+          <p:nvPr/>
+        </p:nvSpPr>
+        <p:spPr>
+          <a:xfrm>
+            <a:off x="685800" y="5715000"/>
+            <a:ext cx="10817352" cy="658368"/>
           </a:xfrm>
           <a:prstGeom prst="roundRect">
             <a:avLst>
-              <a:gd name="adj" fmla="val 5333"/>
+              <a:gd name="adj" fmla="val 11111"/>
             </a:avLst>
           </a:prstGeom>
           <a:solidFill>
-            <a:srgbClr val="F1F6F3"/>
+            <a:srgbClr val="0E2A22"/>
           </a:solidFill>
           <a:ln w="12700">
             <a:solidFill>
-              <a:srgbClr val="F1F6F3"/>
+              <a:srgbClr val="0E2A22"/>
             </a:solidFill>
             <a:prstDash val="solid"/>
           </a:ln>
@@ -7675,53 +8538,14 @@
       </p:sp>
       <p:sp>
         <p:nvSpPr>
-          <p:cNvPr id="19" name="Text 17"/>
-          <p:cNvSpPr/>
-          <p:nvPr/>
-        </p:nvSpPr>
-        <p:spPr>
-          <a:xfrm>
-            <a:off x="1097280" y="4572000"/>
-            <a:ext cx="2743200" cy="320040"/>
-          </a:xfrm>
-          <a:prstGeom prst="rect">
-            <a:avLst/>
-          </a:prstGeom>
-          <a:noFill/>
-          <a:ln/>
-        </p:spPr>
-        <p:txBody>
-          <a:bodyPr wrap="square" lIns="0" tIns="0" rIns="0" bIns="0" rtlCol="0" anchor="ctr"/>
-          <a:lstStyle/>
-          <a:p>
-            <a:pPr indent="0" marL="0">
-              <a:buNone/>
-            </a:pPr>
-            <a:r>
-              <a:rPr lang="en-US" sz="1400" b="1" dirty="0">
-                <a:solidFill>
-                  <a:srgbClr val="00C878"/>
-                </a:solidFill>
-                <a:latin typeface="Calibri" pitchFamily="34" charset="0"/>
-                <a:ea typeface="Calibri" pitchFamily="34" charset="-122"/>
-                <a:cs typeface="Calibri" pitchFamily="34" charset="-120"/>
-              </a:rPr>
-              <a:t>확장 가능성</a:t>
-            </a:r>
-            <a:endParaRPr lang="en-US" sz="1400" dirty="0"/>
-          </a:p>
-        </p:txBody>
-      </p:sp>
-      <p:sp>
-        <p:nvSpPr>
           <p:cNvPr id="20" name="Text 18"/>
           <p:cNvSpPr/>
           <p:nvPr/>
         </p:nvSpPr>
         <p:spPr>
           <a:xfrm>
-            <a:off x="1097280" y="4919472"/>
-            <a:ext cx="9994392" cy="731520"/>
+            <a:off x="1097280" y="5715000"/>
+            <a:ext cx="9994392" cy="658368"/>
           </a:xfrm>
           <a:prstGeom prst="rect">
             <a:avLst/>
@@ -7739,54 +8563,15 @@
             <a:r>
               <a:rPr lang="en-US" sz="1500" dirty="0">
                 <a:solidFill>
-                  <a:srgbClr val="15211D"/>
-                </a:solidFill>
-                <a:latin typeface="Calibri" pitchFamily="34" charset="0"/>
-                <a:ea typeface="Calibri" pitchFamily="34" charset="-122"/>
-                <a:cs typeface="Calibri" pitchFamily="34" charset="-120"/>
-              </a:rPr>
-              <a:t>동일한 구조를 경조사 안내, 근속 축하, 교육 이수 리마인드 등 피플실의 다른 정기 안내 업무에 그대로 적용할 수 있습니다.</a:t>
+                  <a:srgbClr val="FFFFFF"/>
+                </a:solidFill>
+                <a:latin typeface="Calibri" pitchFamily="34" charset="0"/>
+                <a:ea typeface="Calibri" pitchFamily="34" charset="-122"/>
+                <a:cs typeface="Calibri" pitchFamily="34" charset="-120"/>
+              </a:rPr>
+              <a:t>매월 ERP 최신본만 붙여넣으면, 휴직 · 퇴직 · 신규 입사자가 자동으로 반영됩니다</a:t>
             </a:r>
             <a:endParaRPr lang="en-US" sz="1500" dirty="0"/>
-          </a:p>
-        </p:txBody>
-      </p:sp>
-      <p:sp>
-        <p:nvSpPr>
-          <p:cNvPr id="21" name="Text 19"/>
-          <p:cNvSpPr/>
-          <p:nvPr/>
-        </p:nvSpPr>
-        <p:spPr>
-          <a:xfrm>
-            <a:off x="685800" y="6400800"/>
-            <a:ext cx="10817352" cy="274320"/>
-          </a:xfrm>
-          <a:prstGeom prst="rect">
-            <a:avLst/>
-          </a:prstGeom>
-          <a:noFill/>
-          <a:ln/>
-        </p:spPr>
-        <p:txBody>
-          <a:bodyPr wrap="square" lIns="0" tIns="0" rIns="0" bIns="0" rtlCol="0" anchor="ctr"/>
-          <a:lstStyle/>
-          <a:p>
-            <a:pPr algn="l" indent="0" marL="0">
-              <a:buNone/>
-            </a:pPr>
-            <a:r>
-              <a:rPr lang="en-US" sz="1000" dirty="0">
-                <a:solidFill>
-                  <a:srgbClr val="5F7069"/>
-                </a:solidFill>
-                <a:latin typeface="Calibri" pitchFamily="34" charset="0"/>
-                <a:ea typeface="Calibri" pitchFamily="34" charset="-122"/>
-                <a:cs typeface="Calibri" pitchFamily="34" charset="-120"/>
-              </a:rPr>
-              <a:t>※ 작업 시간은 대상자 13~22명 기준 추정치</a:t>
-            </a:r>
-            <a:endParaRPr lang="en-US" sz="1000" dirty="0"/>
           </a:p>
         </p:txBody>
       </p:sp>
@@ -7801,13 +8586,6 @@
 <file path=ppt/slides/slide9.xml><?xml version="1.0" encoding="utf-8"?>
 <p:sld xmlns:a="http://schemas.openxmlformats.org/drawingml/2006/main" xmlns:r="http://schemas.openxmlformats.org/officeDocument/2006/relationships" xmlns:p="http://schemas.openxmlformats.org/presentationml/2006/main">
   <p:cSld name="Slide 9">
-    <p:bg>
-      <p:bgPr>
-        <a:solidFill>
-          <a:srgbClr val="0E2A22"/>
-        </a:solidFill>
-      </p:bgPr>
-    </p:bg>
     <p:spTree>
       <p:nvGrpSpPr>
         <p:cNvPr id="1" name=""/>
@@ -7824,34 +8602,14 @@
       </p:grpSpPr>
       <p:sp>
         <p:nvSpPr>
-          <p:cNvPr id="2" name="Shape 0"/>
-          <p:cNvSpPr/>
-          <p:nvPr/>
-        </p:nvSpPr>
-        <p:spPr>
-          <a:xfrm>
-            <a:off x="10241280" y="-1097280"/>
-            <a:ext cx="3474720" cy="3474720"/>
-          </a:xfrm>
-          <a:prstGeom prst="ellipse">
-            <a:avLst/>
-          </a:prstGeom>
-          <a:solidFill>
-            <a:srgbClr val="173A2E"/>
-          </a:solidFill>
-          <a:ln/>
-        </p:spPr>
-      </p:sp>
-      <p:sp>
-        <p:nvSpPr>
-          <p:cNvPr id="3" name="Text 1"/>
-          <p:cNvSpPr/>
-          <p:nvPr/>
-        </p:nvSpPr>
-        <p:spPr>
-          <a:xfrm>
-            <a:off x="685800" y="685800"/>
-            <a:ext cx="10817352" cy="731520"/>
+          <p:cNvPr id="2" name="Text 0"/>
+          <p:cNvSpPr/>
+          <p:nvPr/>
+        </p:nvSpPr>
+        <p:spPr>
+          <a:xfrm>
+            <a:off x="685800" y="457200"/>
+            <a:ext cx="10817352" cy="685800"/>
           </a:xfrm>
           <a:prstGeom prst="rect">
             <a:avLst/>
@@ -7869,13 +8627,13 @@
             <a:r>
               <a:rPr lang="en-US" sz="3800" b="1" dirty="0">
                 <a:solidFill>
-                  <a:srgbClr val="FFFFFF"/>
-                </a:solidFill>
-                <a:latin typeface="Calibri" pitchFamily="34" charset="0"/>
-                <a:ea typeface="Calibri" pitchFamily="34" charset="-122"/>
-                <a:cs typeface="Calibri" pitchFamily="34" charset="-120"/>
-              </a:rPr>
-              <a:t>향후 계획</a:t>
+                  <a:srgbClr val="15211D"/>
+                </a:solidFill>
+                <a:latin typeface="Calibri" pitchFamily="34" charset="0"/>
+                <a:ea typeface="Calibri" pitchFamily="34" charset="-122"/>
+                <a:cs typeface="Calibri" pitchFamily="34" charset="-120"/>
+              </a:rPr>
+              <a:t>기대 효과</a:t>
             </a:r>
             <a:endParaRPr lang="en-US" sz="3800" dirty="0"/>
           </a:p>
@@ -7883,26 +8641,26 @@
       </p:sp>
       <p:sp>
         <p:nvSpPr>
-          <p:cNvPr id="4" name="Shape 2"/>
-          <p:cNvSpPr/>
-          <p:nvPr/>
-        </p:nvSpPr>
-        <p:spPr>
-          <a:xfrm>
-            <a:off x="685800" y="1828800"/>
-            <a:ext cx="10817352" cy="960120"/>
+          <p:cNvPr id="3" name="Shape 1"/>
+          <p:cNvSpPr/>
+          <p:nvPr/>
+        </p:nvSpPr>
+        <p:spPr>
+          <a:xfrm>
+            <a:off x="685800" y="1737360"/>
+            <a:ext cx="3331464" cy="2377440"/>
           </a:xfrm>
           <a:prstGeom prst="roundRect">
             <a:avLst>
-              <a:gd name="adj" fmla="val 7619"/>
+              <a:gd name="adj" fmla="val 3077"/>
             </a:avLst>
           </a:prstGeom>
           <a:solidFill>
-            <a:srgbClr val="15352A"/>
+            <a:srgbClr val="F1F6F3"/>
           </a:solidFill>
           <a:ln w="12700">
             <a:solidFill>
-              <a:srgbClr val="15352A"/>
+              <a:srgbClr val="F1F6F3"/>
             </a:solidFill>
             <a:prstDash val="solid"/>
           </a:ln>
@@ -7910,23 +8668,81 @@
       </p:sp>
       <p:sp>
         <p:nvSpPr>
-          <p:cNvPr id="5" name="Shape 3"/>
-          <p:cNvSpPr/>
-          <p:nvPr/>
-        </p:nvSpPr>
-        <p:spPr>
-          <a:xfrm>
-            <a:off x="1005840" y="2084832"/>
-            <a:ext cx="438912" cy="438912"/>
-          </a:xfrm>
-          <a:prstGeom prst="ellipse">
-            <a:avLst/>
-          </a:prstGeom>
-          <a:solidFill>
-            <a:srgbClr val="00C878"/>
-          </a:solidFill>
-          <a:ln/>
-        </p:spPr>
+          <p:cNvPr id="4" name="Text 2"/>
+          <p:cNvSpPr/>
+          <p:nvPr/>
+        </p:nvSpPr>
+        <p:spPr>
+          <a:xfrm>
+            <a:off x="978408" y="1965960"/>
+            <a:ext cx="2746248" cy="292608"/>
+          </a:xfrm>
+          <a:prstGeom prst="rect">
+            <a:avLst/>
+          </a:prstGeom>
+          <a:noFill/>
+          <a:ln/>
+        </p:spPr>
+        <p:txBody>
+          <a:bodyPr wrap="square" lIns="0" tIns="0" rIns="0" bIns="0" rtlCol="0" anchor="ctr"/>
+          <a:lstStyle/>
+          <a:p>
+            <a:pPr indent="0" marL="0">
+              <a:buNone/>
+            </a:pPr>
+            <a:r>
+              <a:rPr lang="en-US" sz="1200" b="1" spc="100" kern="0" dirty="0">
+                <a:solidFill>
+                  <a:srgbClr val="5F7069"/>
+                </a:solidFill>
+                <a:latin typeface="Calibri" pitchFamily="34" charset="0"/>
+                <a:ea typeface="Calibri" pitchFamily="34" charset="-122"/>
+                <a:cs typeface="Calibri" pitchFamily="34" charset="-120"/>
+              </a:rPr>
+              <a:t>작업 시간</a:t>
+            </a:r>
+            <a:endParaRPr lang="en-US" sz="1200" dirty="0"/>
+          </a:p>
+        </p:txBody>
+      </p:sp>
+      <p:sp>
+        <p:nvSpPr>
+          <p:cNvPr id="5" name="Text 3"/>
+          <p:cNvSpPr/>
+          <p:nvPr/>
+        </p:nvSpPr>
+        <p:spPr>
+          <a:xfrm>
+            <a:off x="978408" y="2359152"/>
+            <a:ext cx="2746248" cy="457200"/>
+          </a:xfrm>
+          <a:prstGeom prst="rect">
+            <a:avLst/>
+          </a:prstGeom>
+          <a:noFill/>
+          <a:ln/>
+        </p:spPr>
+        <p:txBody>
+          <a:bodyPr wrap="square" lIns="0" tIns="0" rIns="0" bIns="0" rtlCol="0" anchor="ctr"/>
+          <a:lstStyle/>
+          <a:p>
+            <a:pPr indent="0" marL="0">
+              <a:buNone/>
+            </a:pPr>
+            <a:r>
+              <a:rPr lang="en-US" sz="1500" strike="sngStrike" dirty="0">
+                <a:solidFill>
+                  <a:srgbClr val="96A6A0"/>
+                </a:solidFill>
+                <a:latin typeface="Calibri" pitchFamily="34" charset="0"/>
+                <a:ea typeface="Calibri" pitchFamily="34" charset="-122"/>
+                <a:cs typeface="Calibri" pitchFamily="34" charset="-120"/>
+              </a:rPr>
+              <a:t>월 1.5~2시간</a:t>
+            </a:r>
+            <a:endParaRPr lang="en-US" sz="1500" dirty="0"/>
+          </a:p>
+        </p:txBody>
       </p:sp>
       <p:sp>
         <p:nvSpPr>
@@ -7936,32 +8752,32 @@
         </p:nvSpPr>
         <p:spPr>
           <a:xfrm>
-            <a:off x="1005840" y="2084832"/>
-            <a:ext cx="438912" cy="438912"/>
-          </a:xfrm>
-          <a:prstGeom prst="rect">
-            <a:avLst/>
-          </a:prstGeom>
-          <a:noFill/>
-          <a:ln/>
-        </p:spPr>
-        <p:txBody>
-          <a:bodyPr wrap="square" lIns="0" tIns="0" rIns="0" bIns="0" rtlCol="0" anchor="ctr"/>
-          <a:lstStyle/>
-          <a:p>
-            <a:pPr algn="ctr" indent="0" marL="0">
-              <a:buNone/>
-            </a:pPr>
-            <a:r>
-              <a:rPr lang="en-US" sz="1400" b="1" dirty="0">
-                <a:solidFill>
-                  <a:srgbClr val="FFFFFF"/>
-                </a:solidFill>
-                <a:latin typeface="Calibri" pitchFamily="34" charset="0"/>
-                <a:ea typeface="Calibri" pitchFamily="34" charset="-122"/>
-                <a:cs typeface="Calibri" pitchFamily="34" charset="-120"/>
-              </a:rPr>
-              <a:t>1</a:t>
+            <a:off x="978408" y="2816352"/>
+            <a:ext cx="2746248" cy="292608"/>
+          </a:xfrm>
+          <a:prstGeom prst="rect">
+            <a:avLst/>
+          </a:prstGeom>
+          <a:noFill/>
+          <a:ln/>
+        </p:spPr>
+        <p:txBody>
+          <a:bodyPr wrap="square" lIns="0" tIns="0" rIns="0" bIns="0" rtlCol="0" anchor="ctr"/>
+          <a:lstStyle/>
+          <a:p>
+            <a:pPr indent="0" marL="0">
+              <a:buNone/>
+            </a:pPr>
+            <a:r>
+              <a:rPr lang="en-US" sz="1400" dirty="0">
+                <a:solidFill>
+                  <a:srgbClr val="00C878"/>
+                </a:solidFill>
+                <a:latin typeface="Calibri" pitchFamily="34" charset="0"/>
+                <a:ea typeface="Calibri" pitchFamily="34" charset="-122"/>
+                <a:cs typeface="Calibri" pitchFamily="34" charset="-120"/>
+              </a:rPr>
+              <a:t>↓</a:t>
             </a:r>
             <a:endParaRPr lang="en-US" sz="1400" dirty="0"/>
           </a:p>
@@ -7975,98 +8791,59 @@
         </p:nvSpPr>
         <p:spPr>
           <a:xfrm>
-            <a:off x="1645920" y="1956816"/>
-            <a:ext cx="3291840" cy="365760"/>
-          </a:xfrm>
-          <a:prstGeom prst="rect">
-            <a:avLst/>
-          </a:prstGeom>
-          <a:noFill/>
-          <a:ln/>
-        </p:spPr>
-        <p:txBody>
-          <a:bodyPr wrap="square" lIns="0" tIns="0" rIns="0" bIns="0" rtlCol="0" anchor="ctr"/>
-          <a:lstStyle/>
-          <a:p>
-            <a:pPr indent="0" marL="0">
-              <a:buNone/>
-            </a:pPr>
-            <a:r>
-              <a:rPr lang="en-US" sz="1700" b="1" dirty="0">
-                <a:solidFill>
-                  <a:srgbClr val="FFFFFF"/>
-                </a:solidFill>
-                <a:latin typeface="Calibri" pitchFamily="34" charset="0"/>
-                <a:ea typeface="Calibri" pitchFamily="34" charset="-122"/>
-                <a:cs typeface="Calibri" pitchFamily="34" charset="-120"/>
-              </a:rPr>
-              <a:t>회사 로고 서명 적용</a:t>
-            </a:r>
-            <a:endParaRPr lang="en-US" sz="1700" dirty="0"/>
-          </a:p>
-        </p:txBody>
-      </p:sp>
-      <p:sp>
-        <p:nvSpPr>
-          <p:cNvPr id="8" name="Text 6"/>
-          <p:cNvSpPr/>
-          <p:nvPr/>
-        </p:nvSpPr>
-        <p:spPr>
-          <a:xfrm>
-            <a:off x="5120640" y="1956816"/>
-            <a:ext cx="6062472" cy="704088"/>
-          </a:xfrm>
-          <a:prstGeom prst="rect">
-            <a:avLst/>
-          </a:prstGeom>
-          <a:noFill/>
-          <a:ln/>
-        </p:spPr>
-        <p:txBody>
-          <a:bodyPr wrap="square" lIns="0" tIns="0" rIns="0" bIns="0" rtlCol="0" anchor="ctr"/>
-          <a:lstStyle/>
-          <a:p>
-            <a:pPr indent="0" marL="0">
-              <a:buNone/>
-            </a:pPr>
-            <a:r>
-              <a:rPr lang="en-US" sz="1350" dirty="0">
-                <a:solidFill>
-                  <a:srgbClr val="A9C3B6"/>
-                </a:solidFill>
-                <a:latin typeface="Calibri" pitchFamily="34" charset="0"/>
-                <a:ea typeface="Calibri" pitchFamily="34" charset="-122"/>
-                <a:cs typeface="Calibri" pitchFamily="34" charset="-120"/>
-              </a:rPr>
-              <a:t>Gmail 서명 연동을 완료해 브랜드 서명이 자동 첨부되도록 설정</a:t>
-            </a:r>
-            <a:endParaRPr lang="en-US" sz="1350" dirty="0"/>
-          </a:p>
-        </p:txBody>
-      </p:sp>
-      <p:sp>
-        <p:nvSpPr>
-          <p:cNvPr id="9" name="Shape 7"/>
-          <p:cNvSpPr/>
-          <p:nvPr/>
-        </p:nvSpPr>
-        <p:spPr>
-          <a:xfrm>
-            <a:off x="685800" y="2971800"/>
-            <a:ext cx="10817352" cy="960120"/>
+            <a:off x="978408" y="3127248"/>
+            <a:ext cx="2746248" cy="777240"/>
+          </a:xfrm>
+          <a:prstGeom prst="rect">
+            <a:avLst/>
+          </a:prstGeom>
+          <a:noFill/>
+          <a:ln/>
+        </p:spPr>
+        <p:txBody>
+          <a:bodyPr wrap="square" lIns="0" tIns="0" rIns="0" bIns="0" rtlCol="0" anchor="ctr"/>
+          <a:lstStyle/>
+          <a:p>
+            <a:pPr indent="0" marL="0">
+              <a:buNone/>
+            </a:pPr>
+            <a:r>
+              <a:rPr lang="en-US" sz="2100" b="1" dirty="0">
+                <a:solidFill>
+                  <a:srgbClr val="15211D"/>
+                </a:solidFill>
+                <a:latin typeface="Calibri" pitchFamily="34" charset="0"/>
+                <a:ea typeface="Calibri" pitchFamily="34" charset="-122"/>
+                <a:cs typeface="Calibri" pitchFamily="34" charset="-120"/>
+              </a:rPr>
+              <a:t>5분 이내</a:t>
+            </a:r>
+            <a:endParaRPr lang="en-US" sz="2100" dirty="0"/>
+          </a:p>
+        </p:txBody>
+      </p:sp>
+      <p:sp>
+        <p:nvSpPr>
+          <p:cNvPr id="8" name="Shape 6"/>
+          <p:cNvSpPr/>
+          <p:nvPr/>
+        </p:nvSpPr>
+        <p:spPr>
+          <a:xfrm>
+            <a:off x="4428744" y="1737360"/>
+            <a:ext cx="3331464" cy="2377440"/>
           </a:xfrm>
           <a:prstGeom prst="roundRect">
             <a:avLst>
-              <a:gd name="adj" fmla="val 7619"/>
+              <a:gd name="adj" fmla="val 3077"/>
             </a:avLst>
           </a:prstGeom>
           <a:solidFill>
-            <a:srgbClr val="15352A"/>
+            <a:srgbClr val="F1F6F3"/>
           </a:solidFill>
           <a:ln w="12700">
             <a:solidFill>
-              <a:srgbClr val="15352A"/>
+              <a:srgbClr val="F1F6F3"/>
             </a:solidFill>
             <a:prstDash val="solid"/>
           </a:ln>
@@ -8074,23 +8851,81 @@
       </p:sp>
       <p:sp>
         <p:nvSpPr>
-          <p:cNvPr id="10" name="Shape 8"/>
-          <p:cNvSpPr/>
-          <p:nvPr/>
-        </p:nvSpPr>
-        <p:spPr>
-          <a:xfrm>
-            <a:off x="1005840" y="3227832"/>
-            <a:ext cx="438912" cy="438912"/>
-          </a:xfrm>
-          <a:prstGeom prst="ellipse">
-            <a:avLst/>
-          </a:prstGeom>
-          <a:solidFill>
-            <a:srgbClr val="00C878"/>
-          </a:solidFill>
-          <a:ln/>
-        </p:spPr>
+          <p:cNvPr id="9" name="Text 7"/>
+          <p:cNvSpPr/>
+          <p:nvPr/>
+        </p:nvSpPr>
+        <p:spPr>
+          <a:xfrm>
+            <a:off x="4721352" y="1965960"/>
+            <a:ext cx="2746248" cy="292608"/>
+          </a:xfrm>
+          <a:prstGeom prst="rect">
+            <a:avLst/>
+          </a:prstGeom>
+          <a:noFill/>
+          <a:ln/>
+        </p:spPr>
+        <p:txBody>
+          <a:bodyPr wrap="square" lIns="0" tIns="0" rIns="0" bIns="0" rtlCol="0" anchor="ctr"/>
+          <a:lstStyle/>
+          <a:p>
+            <a:pPr indent="0" marL="0">
+              <a:buNone/>
+            </a:pPr>
+            <a:r>
+              <a:rPr lang="en-US" sz="1200" b="1" spc="100" kern="0" dirty="0">
+                <a:solidFill>
+                  <a:srgbClr val="5F7069"/>
+                </a:solidFill>
+                <a:latin typeface="Calibri" pitchFamily="34" charset="0"/>
+                <a:ea typeface="Calibri" pitchFamily="34" charset="-122"/>
+                <a:cs typeface="Calibri" pitchFamily="34" charset="-120"/>
+              </a:rPr>
+              <a:t>대상자 선별</a:t>
+            </a:r>
+            <a:endParaRPr lang="en-US" sz="1200" dirty="0"/>
+          </a:p>
+        </p:txBody>
+      </p:sp>
+      <p:sp>
+        <p:nvSpPr>
+          <p:cNvPr id="10" name="Text 8"/>
+          <p:cNvSpPr/>
+          <p:nvPr/>
+        </p:nvSpPr>
+        <p:spPr>
+          <a:xfrm>
+            <a:off x="4721352" y="2359152"/>
+            <a:ext cx="2746248" cy="457200"/>
+          </a:xfrm>
+          <a:prstGeom prst="rect">
+            <a:avLst/>
+          </a:prstGeom>
+          <a:noFill/>
+          <a:ln/>
+        </p:spPr>
+        <p:txBody>
+          <a:bodyPr wrap="square" lIns="0" tIns="0" rIns="0" bIns="0" rtlCol="0" anchor="ctr"/>
+          <a:lstStyle/>
+          <a:p>
+            <a:pPr indent="0" marL="0">
+              <a:buNone/>
+            </a:pPr>
+            <a:r>
+              <a:rPr lang="en-US" sz="1500" strike="sngStrike" dirty="0">
+                <a:solidFill>
+                  <a:srgbClr val="96A6A0"/>
+                </a:solidFill>
+                <a:latin typeface="Calibri" pitchFamily="34" charset="0"/>
+                <a:ea typeface="Calibri" pitchFamily="34" charset="-122"/>
+                <a:cs typeface="Calibri" pitchFamily="34" charset="-120"/>
+              </a:rPr>
+              <a:t>수작업 대조</a:t>
+            </a:r>
+            <a:endParaRPr lang="en-US" sz="1500" dirty="0"/>
+          </a:p>
+        </p:txBody>
       </p:sp>
       <p:sp>
         <p:nvSpPr>
@@ -8100,32 +8935,32 @@
         </p:nvSpPr>
         <p:spPr>
           <a:xfrm>
-            <a:off x="1005840" y="3227832"/>
-            <a:ext cx="438912" cy="438912"/>
-          </a:xfrm>
-          <a:prstGeom prst="rect">
-            <a:avLst/>
-          </a:prstGeom>
-          <a:noFill/>
-          <a:ln/>
-        </p:spPr>
-        <p:txBody>
-          <a:bodyPr wrap="square" lIns="0" tIns="0" rIns="0" bIns="0" rtlCol="0" anchor="ctr"/>
-          <a:lstStyle/>
-          <a:p>
-            <a:pPr algn="ctr" indent="0" marL="0">
-              <a:buNone/>
-            </a:pPr>
-            <a:r>
-              <a:rPr lang="en-US" sz="1400" b="1" dirty="0">
-                <a:solidFill>
-                  <a:srgbClr val="FFFFFF"/>
-                </a:solidFill>
-                <a:latin typeface="Calibri" pitchFamily="34" charset="0"/>
-                <a:ea typeface="Calibri" pitchFamily="34" charset="-122"/>
-                <a:cs typeface="Calibri" pitchFamily="34" charset="-120"/>
-              </a:rPr>
-              <a:t>2</a:t>
+            <a:off x="4721352" y="2816352"/>
+            <a:ext cx="2746248" cy="292608"/>
+          </a:xfrm>
+          <a:prstGeom prst="rect">
+            <a:avLst/>
+          </a:prstGeom>
+          <a:noFill/>
+          <a:ln/>
+        </p:spPr>
+        <p:txBody>
+          <a:bodyPr wrap="square" lIns="0" tIns="0" rIns="0" bIns="0" rtlCol="0" anchor="ctr"/>
+          <a:lstStyle/>
+          <a:p>
+            <a:pPr indent="0" marL="0">
+              <a:buNone/>
+            </a:pPr>
+            <a:r>
+              <a:rPr lang="en-US" sz="1400" dirty="0">
+                <a:solidFill>
+                  <a:srgbClr val="00C878"/>
+                </a:solidFill>
+                <a:latin typeface="Calibri" pitchFamily="34" charset="0"/>
+                <a:ea typeface="Calibri" pitchFamily="34" charset="-122"/>
+                <a:cs typeface="Calibri" pitchFamily="34" charset="-120"/>
+              </a:rPr>
+              <a:t>↓</a:t>
             </a:r>
             <a:endParaRPr lang="en-US" sz="1400" dirty="0"/>
           </a:p>
@@ -8139,98 +8974,59 @@
         </p:nvSpPr>
         <p:spPr>
           <a:xfrm>
-            <a:off x="1645920" y="3099816"/>
-            <a:ext cx="3291840" cy="365760"/>
-          </a:xfrm>
-          <a:prstGeom prst="rect">
-            <a:avLst/>
-          </a:prstGeom>
-          <a:noFill/>
-          <a:ln/>
-        </p:spPr>
-        <p:txBody>
-          <a:bodyPr wrap="square" lIns="0" tIns="0" rIns="0" bIns="0" rtlCol="0" anchor="ctr"/>
-          <a:lstStyle/>
-          <a:p>
-            <a:pPr indent="0" marL="0">
-              <a:buNone/>
-            </a:pPr>
-            <a:r>
-              <a:rPr lang="en-US" sz="1700" b="1" dirty="0">
-                <a:solidFill>
-                  <a:srgbClr val="FFFFFF"/>
-                </a:solidFill>
-                <a:latin typeface="Calibri" pitchFamily="34" charset="0"/>
-                <a:ea typeface="Calibri" pitchFamily="34" charset="-122"/>
-                <a:cs typeface="Calibri" pitchFamily="34" charset="-120"/>
-              </a:rPr>
-              <a:t>운영 계정 이관 검토</a:t>
-            </a:r>
-            <a:endParaRPr lang="en-US" sz="1700" dirty="0"/>
-          </a:p>
-        </p:txBody>
-      </p:sp>
-      <p:sp>
-        <p:nvSpPr>
-          <p:cNvPr id="13" name="Text 11"/>
-          <p:cNvSpPr/>
-          <p:nvPr/>
-        </p:nvSpPr>
-        <p:spPr>
-          <a:xfrm>
-            <a:off x="5120640" y="3099816"/>
-            <a:ext cx="6062472" cy="704088"/>
-          </a:xfrm>
-          <a:prstGeom prst="rect">
-            <a:avLst/>
-          </a:prstGeom>
-          <a:noFill/>
-          <a:ln/>
-        </p:spPr>
-        <p:txBody>
-          <a:bodyPr wrap="square" lIns="0" tIns="0" rIns="0" bIns="0" rtlCol="0" anchor="ctr"/>
-          <a:lstStyle/>
-          <a:p>
-            <a:pPr indent="0" marL="0">
-              <a:buNone/>
-            </a:pPr>
-            <a:r>
-              <a:rPr lang="en-US" sz="1350" dirty="0">
-                <a:solidFill>
-                  <a:srgbClr val="A9C3B6"/>
-                </a:solidFill>
-                <a:latin typeface="Calibri" pitchFamily="34" charset="0"/>
-                <a:ea typeface="Calibri" pitchFamily="34" charset="-122"/>
-                <a:cs typeface="Calibri" pitchFamily="34" charset="-120"/>
-              </a:rPr>
-              <a:t>개인 계정 종속을 없애기 위해 팀 공용 계정 또는 담당자 계정으로 이전</a:t>
-            </a:r>
-            <a:endParaRPr lang="en-US" sz="1350" dirty="0"/>
-          </a:p>
-        </p:txBody>
-      </p:sp>
-      <p:sp>
-        <p:nvSpPr>
-          <p:cNvPr id="14" name="Shape 12"/>
-          <p:cNvSpPr/>
-          <p:nvPr/>
-        </p:nvSpPr>
-        <p:spPr>
-          <a:xfrm>
-            <a:off x="685800" y="4114800"/>
-            <a:ext cx="10817352" cy="960120"/>
+            <a:off x="4721352" y="3127248"/>
+            <a:ext cx="2746248" cy="777240"/>
+          </a:xfrm>
+          <a:prstGeom prst="rect">
+            <a:avLst/>
+          </a:prstGeom>
+          <a:noFill/>
+          <a:ln/>
+        </p:spPr>
+        <p:txBody>
+          <a:bodyPr wrap="square" lIns="0" tIns="0" rIns="0" bIns="0" rtlCol="0" anchor="ctr"/>
+          <a:lstStyle/>
+          <a:p>
+            <a:pPr indent="0" marL="0">
+              <a:buNone/>
+            </a:pPr>
+            <a:r>
+              <a:rPr lang="en-US" sz="2100" b="1" dirty="0">
+                <a:solidFill>
+                  <a:srgbClr val="15211D"/>
+                </a:solidFill>
+                <a:latin typeface="Calibri" pitchFamily="34" charset="0"/>
+                <a:ea typeface="Calibri" pitchFamily="34" charset="-122"/>
+                <a:cs typeface="Calibri" pitchFamily="34" charset="-120"/>
+              </a:rPr>
+              <a:t>규칙 기반 자동 판별</a:t>
+            </a:r>
+            <a:endParaRPr lang="en-US" sz="2100" dirty="0"/>
+          </a:p>
+        </p:txBody>
+      </p:sp>
+      <p:sp>
+        <p:nvSpPr>
+          <p:cNvPr id="13" name="Shape 11"/>
+          <p:cNvSpPr/>
+          <p:nvPr/>
+        </p:nvSpPr>
+        <p:spPr>
+          <a:xfrm>
+            <a:off x="8171688" y="1737360"/>
+            <a:ext cx="3331464" cy="2377440"/>
           </a:xfrm>
           <a:prstGeom prst="roundRect">
             <a:avLst>
-              <a:gd name="adj" fmla="val 7619"/>
+              <a:gd name="adj" fmla="val 3077"/>
             </a:avLst>
           </a:prstGeom>
           <a:solidFill>
-            <a:srgbClr val="15352A"/>
+            <a:srgbClr val="F1F6F3"/>
           </a:solidFill>
           <a:ln w="12700">
             <a:solidFill>
-              <a:srgbClr val="15352A"/>
+              <a:srgbClr val="F1F6F3"/>
             </a:solidFill>
             <a:prstDash val="solid"/>
           </a:ln>
@@ -8238,58 +9034,221 @@
       </p:sp>
       <p:sp>
         <p:nvSpPr>
-          <p:cNvPr id="15" name="Shape 13"/>
-          <p:cNvSpPr/>
-          <p:nvPr/>
-        </p:nvSpPr>
-        <p:spPr>
-          <a:xfrm>
-            <a:off x="1005840" y="4370832"/>
-            <a:ext cx="438912" cy="438912"/>
-          </a:xfrm>
-          <a:prstGeom prst="ellipse">
-            <a:avLst/>
+          <p:cNvPr id="14" name="Text 12"/>
+          <p:cNvSpPr/>
+          <p:nvPr/>
+        </p:nvSpPr>
+        <p:spPr>
+          <a:xfrm>
+            <a:off x="8464296" y="1965960"/>
+            <a:ext cx="2746248" cy="292608"/>
+          </a:xfrm>
+          <a:prstGeom prst="rect">
+            <a:avLst/>
+          </a:prstGeom>
+          <a:noFill/>
+          <a:ln/>
+        </p:spPr>
+        <p:txBody>
+          <a:bodyPr wrap="square" lIns="0" tIns="0" rIns="0" bIns="0" rtlCol="0" anchor="ctr"/>
+          <a:lstStyle/>
+          <a:p>
+            <a:pPr indent="0" marL="0">
+              <a:buNone/>
+            </a:pPr>
+            <a:r>
+              <a:rPr lang="en-US" sz="1200" b="1" spc="100" kern="0" dirty="0">
+                <a:solidFill>
+                  <a:srgbClr val="5F7069"/>
+                </a:solidFill>
+                <a:latin typeface="Calibri" pitchFamily="34" charset="0"/>
+                <a:ea typeface="Calibri" pitchFamily="34" charset="-122"/>
+                <a:cs typeface="Calibri" pitchFamily="34" charset="-120"/>
+              </a:rPr>
+              <a:t>업무 인수인계</a:t>
+            </a:r>
+            <a:endParaRPr lang="en-US" sz="1200" dirty="0"/>
+          </a:p>
+        </p:txBody>
+      </p:sp>
+      <p:sp>
+        <p:nvSpPr>
+          <p:cNvPr id="15" name="Text 13"/>
+          <p:cNvSpPr/>
+          <p:nvPr/>
+        </p:nvSpPr>
+        <p:spPr>
+          <a:xfrm>
+            <a:off x="8464296" y="2359152"/>
+            <a:ext cx="2746248" cy="457200"/>
+          </a:xfrm>
+          <a:prstGeom prst="rect">
+            <a:avLst/>
+          </a:prstGeom>
+          <a:noFill/>
+          <a:ln/>
+        </p:spPr>
+        <p:txBody>
+          <a:bodyPr wrap="square" lIns="0" tIns="0" rIns="0" bIns="0" rtlCol="0" anchor="ctr"/>
+          <a:lstStyle/>
+          <a:p>
+            <a:pPr indent="0" marL="0">
+              <a:buNone/>
+            </a:pPr>
+            <a:r>
+              <a:rPr lang="en-US" sz="1500" strike="sngStrike" dirty="0">
+                <a:solidFill>
+                  <a:srgbClr val="96A6A0"/>
+                </a:solidFill>
+                <a:latin typeface="Calibri" pitchFamily="34" charset="0"/>
+                <a:ea typeface="Calibri" pitchFamily="34" charset="-122"/>
+                <a:cs typeface="Calibri" pitchFamily="34" charset="-120"/>
+              </a:rPr>
+              <a:t>담당자 기억에 의존</a:t>
+            </a:r>
+            <a:endParaRPr lang="en-US" sz="1500" dirty="0"/>
+          </a:p>
+        </p:txBody>
+      </p:sp>
+      <p:sp>
+        <p:nvSpPr>
+          <p:cNvPr id="16" name="Text 14"/>
+          <p:cNvSpPr/>
+          <p:nvPr/>
+        </p:nvSpPr>
+        <p:spPr>
+          <a:xfrm>
+            <a:off x="8464296" y="2816352"/>
+            <a:ext cx="2746248" cy="292608"/>
+          </a:xfrm>
+          <a:prstGeom prst="rect">
+            <a:avLst/>
+          </a:prstGeom>
+          <a:noFill/>
+          <a:ln/>
+        </p:spPr>
+        <p:txBody>
+          <a:bodyPr wrap="square" lIns="0" tIns="0" rIns="0" bIns="0" rtlCol="0" anchor="ctr"/>
+          <a:lstStyle/>
+          <a:p>
+            <a:pPr indent="0" marL="0">
+              <a:buNone/>
+            </a:pPr>
+            <a:r>
+              <a:rPr lang="en-US" sz="1400" dirty="0">
+                <a:solidFill>
+                  <a:srgbClr val="00C878"/>
+                </a:solidFill>
+                <a:latin typeface="Calibri" pitchFamily="34" charset="0"/>
+                <a:ea typeface="Calibri" pitchFamily="34" charset="-122"/>
+                <a:cs typeface="Calibri" pitchFamily="34" charset="-120"/>
+              </a:rPr>
+              <a:t>↓</a:t>
+            </a:r>
+            <a:endParaRPr lang="en-US" sz="1400" dirty="0"/>
+          </a:p>
+        </p:txBody>
+      </p:sp>
+      <p:sp>
+        <p:nvSpPr>
+          <p:cNvPr id="17" name="Text 15"/>
+          <p:cNvSpPr/>
+          <p:nvPr/>
+        </p:nvSpPr>
+        <p:spPr>
+          <a:xfrm>
+            <a:off x="8464296" y="3127248"/>
+            <a:ext cx="2746248" cy="777240"/>
+          </a:xfrm>
+          <a:prstGeom prst="rect">
+            <a:avLst/>
+          </a:prstGeom>
+          <a:noFill/>
+          <a:ln/>
+        </p:spPr>
+        <p:txBody>
+          <a:bodyPr wrap="square" lIns="0" tIns="0" rIns="0" bIns="0" rtlCol="0" anchor="ctr"/>
+          <a:lstStyle/>
+          <a:p>
+            <a:pPr indent="0" marL="0">
+              <a:buNone/>
+            </a:pPr>
+            <a:r>
+              <a:rPr lang="en-US" sz="2100" b="1" dirty="0">
+                <a:solidFill>
+                  <a:srgbClr val="15211D"/>
+                </a:solidFill>
+                <a:latin typeface="Calibri" pitchFamily="34" charset="0"/>
+                <a:ea typeface="Calibri" pitchFamily="34" charset="-122"/>
+                <a:cs typeface="Calibri" pitchFamily="34" charset="-120"/>
+              </a:rPr>
+              <a:t>문서 · 설정 내장</a:t>
+            </a:r>
+            <a:endParaRPr lang="en-US" sz="2100" dirty="0"/>
+          </a:p>
+        </p:txBody>
+      </p:sp>
+      <p:sp>
+        <p:nvSpPr>
+          <p:cNvPr id="18" name="Shape 16"/>
+          <p:cNvSpPr/>
+          <p:nvPr/>
+        </p:nvSpPr>
+        <p:spPr>
+          <a:xfrm>
+            <a:off x="685800" y="4434840"/>
+            <a:ext cx="10817352" cy="1371600"/>
+          </a:xfrm>
+          <a:prstGeom prst="roundRect">
+            <a:avLst>
+              <a:gd name="adj" fmla="val 5333"/>
+            </a:avLst>
           </a:prstGeom>
           <a:solidFill>
-            <a:srgbClr val="00C878"/>
+            <a:srgbClr val="F1F6F3"/>
           </a:solidFill>
-          <a:ln/>
-        </p:spPr>
-      </p:sp>
-      <p:sp>
-        <p:nvSpPr>
-          <p:cNvPr id="16" name="Text 14"/>
-          <p:cNvSpPr/>
-          <p:nvPr/>
-        </p:nvSpPr>
-        <p:spPr>
-          <a:xfrm>
-            <a:off x="1005840" y="4370832"/>
-            <a:ext cx="438912" cy="438912"/>
-          </a:xfrm>
-          <a:prstGeom prst="rect">
-            <a:avLst/>
-          </a:prstGeom>
-          <a:noFill/>
-          <a:ln/>
-        </p:spPr>
-        <p:txBody>
-          <a:bodyPr wrap="square" lIns="0" tIns="0" rIns="0" bIns="0" rtlCol="0" anchor="ctr"/>
-          <a:lstStyle/>
-          <a:p>
-            <a:pPr algn="ctr" indent="0" marL="0">
+          <a:ln w="12700">
+            <a:solidFill>
+              <a:srgbClr val="F1F6F3"/>
+            </a:solidFill>
+            <a:prstDash val="solid"/>
+          </a:ln>
+        </p:spPr>
+      </p:sp>
+      <p:sp>
+        <p:nvSpPr>
+          <p:cNvPr id="19" name="Text 17"/>
+          <p:cNvSpPr/>
+          <p:nvPr/>
+        </p:nvSpPr>
+        <p:spPr>
+          <a:xfrm>
+            <a:off x="1097280" y="4572000"/>
+            <a:ext cx="2743200" cy="320040"/>
+          </a:xfrm>
+          <a:prstGeom prst="rect">
+            <a:avLst/>
+          </a:prstGeom>
+          <a:noFill/>
+          <a:ln/>
+        </p:spPr>
+        <p:txBody>
+          <a:bodyPr wrap="square" lIns="0" tIns="0" rIns="0" bIns="0" rtlCol="0" anchor="ctr"/>
+          <a:lstStyle/>
+          <a:p>
+            <a:pPr indent="0" marL="0">
               <a:buNone/>
             </a:pPr>
             <a:r>
               <a:rPr lang="en-US" sz="1400" b="1" dirty="0">
                 <a:solidFill>
-                  <a:srgbClr val="FFFFFF"/>
-                </a:solidFill>
-                <a:latin typeface="Calibri" pitchFamily="34" charset="0"/>
-                <a:ea typeface="Calibri" pitchFamily="34" charset="-122"/>
-                <a:cs typeface="Calibri" pitchFamily="34" charset="-120"/>
-              </a:rPr>
-              <a:t>3</a:t>
+                  <a:srgbClr val="00C878"/>
+                </a:solidFill>
+                <a:latin typeface="Calibri" pitchFamily="34" charset="0"/>
+                <a:ea typeface="Calibri" pitchFamily="34" charset="-122"/>
+                <a:cs typeface="Calibri" pitchFamily="34" charset="-120"/>
+              </a:rPr>
+              <a:t>확장 가능성</a:t>
             </a:r>
             <a:endParaRPr lang="en-US" sz="1400" dirty="0"/>
           </a:p>
@@ -8297,118 +9256,79 @@
       </p:sp>
       <p:sp>
         <p:nvSpPr>
-          <p:cNvPr id="17" name="Text 15"/>
-          <p:cNvSpPr/>
-          <p:nvPr/>
-        </p:nvSpPr>
-        <p:spPr>
-          <a:xfrm>
-            <a:off x="1645920" y="4242816"/>
-            <a:ext cx="3291840" cy="365760"/>
-          </a:xfrm>
-          <a:prstGeom prst="rect">
-            <a:avLst/>
-          </a:prstGeom>
-          <a:noFill/>
-          <a:ln/>
-        </p:spPr>
-        <p:txBody>
-          <a:bodyPr wrap="square" lIns="0" tIns="0" rIns="0" bIns="0" rtlCol="0" anchor="ctr"/>
-          <a:lstStyle/>
-          <a:p>
-            <a:pPr indent="0" marL="0">
-              <a:buNone/>
-            </a:pPr>
-            <a:r>
-              <a:rPr lang="en-US" sz="1700" b="1" dirty="0">
-                <a:solidFill>
-                  <a:srgbClr val="FFFFFF"/>
-                </a:solidFill>
-                <a:latin typeface="Calibri" pitchFamily="34" charset="0"/>
-                <a:ea typeface="Calibri" pitchFamily="34" charset="-122"/>
-                <a:cs typeface="Calibri" pitchFamily="34" charset="-120"/>
-              </a:rPr>
-              <a:t>타 업무 확대 적용</a:t>
-            </a:r>
-            <a:endParaRPr lang="en-US" sz="1700" dirty="0"/>
-          </a:p>
-        </p:txBody>
-      </p:sp>
-      <p:sp>
-        <p:nvSpPr>
-          <p:cNvPr id="18" name="Text 16"/>
-          <p:cNvSpPr/>
-          <p:nvPr/>
-        </p:nvSpPr>
-        <p:spPr>
-          <a:xfrm>
-            <a:off x="5120640" y="4242816"/>
-            <a:ext cx="6062472" cy="704088"/>
-          </a:xfrm>
-          <a:prstGeom prst="rect">
-            <a:avLst/>
-          </a:prstGeom>
-          <a:noFill/>
-          <a:ln/>
-        </p:spPr>
-        <p:txBody>
-          <a:bodyPr wrap="square" lIns="0" tIns="0" rIns="0" bIns="0" rtlCol="0" anchor="ctr"/>
-          <a:lstStyle/>
-          <a:p>
-            <a:pPr indent="0" marL="0">
-              <a:buNone/>
-            </a:pPr>
-            <a:r>
-              <a:rPr lang="en-US" sz="1350" dirty="0">
-                <a:solidFill>
-                  <a:srgbClr val="A9C3B6"/>
-                </a:solidFill>
-                <a:latin typeface="Calibri" pitchFamily="34" charset="0"/>
-                <a:ea typeface="Calibri" pitchFamily="34" charset="-122"/>
-                <a:cs typeface="Calibri" pitchFamily="34" charset="-120"/>
-              </a:rPr>
-              <a:t>경조사 · 근속 축하 등 반복 안내 업무에 동일 구조 적용</a:t>
-            </a:r>
-            <a:endParaRPr lang="en-US" sz="1350" dirty="0"/>
-          </a:p>
-        </p:txBody>
-      </p:sp>
-      <p:sp>
-        <p:nvSpPr>
-          <p:cNvPr id="19" name="Text 17"/>
-          <p:cNvSpPr/>
-          <p:nvPr/>
-        </p:nvSpPr>
-        <p:spPr>
-          <a:xfrm>
-            <a:off x="685800" y="5669280"/>
-            <a:ext cx="5486400" cy="457200"/>
-          </a:xfrm>
-          <a:prstGeom prst="rect">
-            <a:avLst/>
-          </a:prstGeom>
-          <a:noFill/>
-          <a:ln/>
-        </p:spPr>
-        <p:txBody>
-          <a:bodyPr wrap="square" lIns="0" tIns="0" rIns="0" bIns="0" rtlCol="0" anchor="ctr"/>
-          <a:lstStyle/>
-          <a:p>
-            <a:pPr indent="0" marL="0">
-              <a:buNone/>
-            </a:pPr>
-            <a:r>
-              <a:rPr lang="en-US" sz="2200" b="1" dirty="0">
-                <a:solidFill>
-                  <a:srgbClr val="00C878"/>
-                </a:solidFill>
-                <a:latin typeface="Calibri" pitchFamily="34" charset="0"/>
-                <a:ea typeface="Calibri" pitchFamily="34" charset="-122"/>
-                <a:cs typeface="Calibri" pitchFamily="34" charset="-120"/>
-              </a:rPr>
-              <a:t>감사합니다</a:t>
-            </a:r>
-            <a:endParaRPr lang="en-US" sz="2200" dirty="0"/>
+          <p:cNvPr id="20" name="Text 18"/>
+          <p:cNvSpPr/>
+          <p:nvPr/>
+        </p:nvSpPr>
+        <p:spPr>
+          <a:xfrm>
+            <a:off x="1097280" y="4919472"/>
+            <a:ext cx="9994392" cy="731520"/>
+          </a:xfrm>
+          <a:prstGeom prst="rect">
+            <a:avLst/>
+          </a:prstGeom>
+          <a:noFill/>
+          <a:ln/>
+        </p:spPr>
+        <p:txBody>
+          <a:bodyPr wrap="square" lIns="0" tIns="0" rIns="0" bIns="0" rtlCol="0" anchor="ctr"/>
+          <a:lstStyle/>
+          <a:p>
+            <a:pPr indent="0" marL="0">
+              <a:buNone/>
+            </a:pPr>
+            <a:r>
+              <a:rPr lang="en-US" sz="1500" dirty="0">
+                <a:solidFill>
+                  <a:srgbClr val="15211D"/>
+                </a:solidFill>
+                <a:latin typeface="Calibri" pitchFamily="34" charset="0"/>
+                <a:ea typeface="Calibri" pitchFamily="34" charset="-122"/>
+                <a:cs typeface="Calibri" pitchFamily="34" charset="-120"/>
+              </a:rPr>
+              <a:t>동일한 구조를 경조사 안내, 근속 축하, 교육 이수 리마인드 등 피플실의 다른 정기 안내 업무에 그대로 적용할 수 있습니다.</a:t>
+            </a:r>
+            <a:endParaRPr lang="en-US" sz="1500" dirty="0"/>
+          </a:p>
+        </p:txBody>
+      </p:sp>
+      <p:sp>
+        <p:nvSpPr>
+          <p:cNvPr id="21" name="Text 19"/>
+          <p:cNvSpPr/>
+          <p:nvPr/>
+        </p:nvSpPr>
+        <p:spPr>
+          <a:xfrm>
+            <a:off x="685800" y="6400800"/>
+            <a:ext cx="10817352" cy="274320"/>
+          </a:xfrm>
+          <a:prstGeom prst="rect">
+            <a:avLst/>
+          </a:prstGeom>
+          <a:noFill/>
+          <a:ln/>
+        </p:spPr>
+        <p:txBody>
+          <a:bodyPr wrap="square" lIns="0" tIns="0" rIns="0" bIns="0" rtlCol="0" anchor="ctr"/>
+          <a:lstStyle/>
+          <a:p>
+            <a:pPr algn="l" indent="0" marL="0">
+              <a:buNone/>
+            </a:pPr>
+            <a:r>
+              <a:rPr lang="en-US" sz="1000" dirty="0">
+                <a:solidFill>
+                  <a:srgbClr val="5F7069"/>
+                </a:solidFill>
+                <a:latin typeface="Calibri" pitchFamily="34" charset="0"/>
+                <a:ea typeface="Calibri" pitchFamily="34" charset="-122"/>
+                <a:cs typeface="Calibri" pitchFamily="34" charset="-120"/>
+              </a:rPr>
+              <a:t>※ 작업 시간은 대상자 13~22명 기준 추정치 · 대상자 선별과 발송 정확도는 8월 운영 결과(15명 전원 발송, 누락 0)로 확인</a:t>
+            </a:r>
+            <a:endParaRPr lang="en-US" sz="1000" dirty="0"/>
           </a:p>
         </p:txBody>
       </p:sp>

</xml_diff>